<commit_message>
Voeg partner-lockup op de cover toe voor klantspecifieke decks
Co-Authored-By: Claude Fable 5 <noreply@anthropic.com>
Claude-Session: https://claude.ai/code/session_0141FN3f3hHkYQHTyvTJJGrw
</commit_message>
<xml_diff>
--- a/output/LINK. kennismaking Sparely.pptx
+++ b/output/LINK. kennismaking Sparely.pptx
@@ -2525,6 +2525,159 @@
           </a:p>
         </p:txBody>
       </p:sp>
+      <p:sp>
+        <p:nvSpPr>
+          <p:cNvPr id="30" name="Text 28"/>
+          <p:cNvSpPr txBox="1"/>
+          <p:nvPr/>
+        </p:nvSpPr>
+        <p:spPr>
+          <a:xfrm>
+            <a:off x="609598" y="5714986"/>
+            <a:ext cx="825498" cy="406399"/>
+          </a:xfrm>
+          <a:prstGeom prst="rect">
+            <a:avLst/>
+          </a:prstGeom>
+          <a:noFill/>
+          <a:ln/>
+        </p:spPr>
+        <p:txBody>
+          <a:bodyPr wrap="square" lIns="0" tIns="0" rIns="0" bIns="0" rtlCol="0" anchor="ctr"/>
+          <a:lstStyle/>
+          <a:p>
+            <a:pPr indent="0" marL="0">
+              <a:buNone/>
+            </a:pPr>
+            <a:r>
+              <a:rPr lang="en-US" sz="1700" b="1" dirty="0">
+                <a:solidFill>
+                  <a:srgbClr val="F2EFE6"/>
+                </a:solidFill>
+                <a:latin typeface="Arial" pitchFamily="34" charset="0"/>
+                <a:ea typeface="Arial" pitchFamily="34" charset="-122"/>
+                <a:cs typeface="Arial" pitchFamily="34" charset="-120"/>
+              </a:rPr>
+              <a:t>LINK</a:t>
+            </a:r>
+            <a:pPr indent="0" marL="0">
+              <a:buNone/>
+            </a:pPr>
+            <a:r>
+              <a:rPr lang="en-US" sz="1700" b="1" dirty="0">
+                <a:solidFill>
+                  <a:srgbClr val="38B6FF"/>
+                </a:solidFill>
+                <a:latin typeface="Arial" pitchFamily="34" charset="0"/>
+                <a:ea typeface="Arial" pitchFamily="34" charset="-122"/>
+                <a:cs typeface="Arial" pitchFamily="34" charset="-120"/>
+              </a:rPr>
+              <a:t>.</a:t>
+            </a:r>
+            <a:endParaRPr lang="en-US" sz="1700" dirty="0"/>
+          </a:p>
+        </p:txBody>
+      </p:sp>
+      <p:sp>
+        <p:nvSpPr>
+          <p:cNvPr id="31" name="Text 29"/>
+          <p:cNvSpPr txBox="1"/>
+          <p:nvPr/>
+        </p:nvSpPr>
+        <p:spPr>
+          <a:xfrm>
+            <a:off x="1473196" y="5714986"/>
+            <a:ext cx="279399" cy="406399"/>
+          </a:xfrm>
+          <a:prstGeom prst="rect">
+            <a:avLst/>
+          </a:prstGeom>
+          <a:noFill/>
+          <a:ln/>
+        </p:spPr>
+        <p:txBody>
+          <a:bodyPr wrap="square" lIns="0" tIns="0" rIns="0" bIns="0" rtlCol="0" anchor="ctr"/>
+          <a:lstStyle/>
+          <a:p>
+            <a:pPr algn="ctr" indent="0" marL="0">
+              <a:buNone/>
+            </a:pPr>
+            <a:r>
+              <a:rPr lang="en-US" sz="1300" dirty="0">
+                <a:solidFill>
+                  <a:srgbClr val="8A90A0"/>
+                </a:solidFill>
+                <a:latin typeface="Arial" pitchFamily="34" charset="0"/>
+                <a:ea typeface="Arial" pitchFamily="34" charset="-122"/>
+                <a:cs typeface="Arial" pitchFamily="34" charset="-120"/>
+              </a:rPr>
+              <a:t>×</a:t>
+            </a:r>
+            <a:endParaRPr lang="en-US" sz="1300" dirty="0"/>
+          </a:p>
+        </p:txBody>
+      </p:sp>
+      <p:sp>
+        <p:nvSpPr>
+          <p:cNvPr id="32" name="Shape 30"/>
+          <p:cNvSpPr/>
+          <p:nvPr/>
+        </p:nvSpPr>
+        <p:spPr>
+          <a:xfrm>
+            <a:off x="1854195" y="5714986"/>
+            <a:ext cx="1396997" cy="406399"/>
+          </a:xfrm>
+          <a:prstGeom prst="roundRect">
+            <a:avLst>
+              <a:gd name="adj" fmla="val 21875"/>
+            </a:avLst>
+          </a:prstGeom>
+          <a:solidFill>
+            <a:srgbClr val="F8F4EB"/>
+          </a:solidFill>
+          <a:ln/>
+        </p:spPr>
+      </p:sp>
+      <p:sp>
+        <p:nvSpPr>
+          <p:cNvPr id="33" name="Text 31"/>
+          <p:cNvSpPr txBox="1"/>
+          <p:nvPr/>
+        </p:nvSpPr>
+        <p:spPr>
+          <a:xfrm>
+            <a:off x="1854195" y="5714986"/>
+            <a:ext cx="1396997" cy="406399"/>
+          </a:xfrm>
+          <a:prstGeom prst="rect">
+            <a:avLst/>
+          </a:prstGeom>
+          <a:noFill/>
+          <a:ln/>
+        </p:spPr>
+        <p:txBody>
+          <a:bodyPr wrap="square" lIns="0" tIns="0" rIns="0" bIns="0" rtlCol="0" anchor="ctr"/>
+          <a:lstStyle/>
+          <a:p>
+            <a:pPr algn="ctr" indent="0" marL="0">
+              <a:buNone/>
+            </a:pPr>
+            <a:r>
+              <a:rPr lang="en-US" sz="1500" b="1" dirty="0">
+                <a:solidFill>
+                  <a:srgbClr val="1C2230"/>
+                </a:solidFill>
+                <a:latin typeface="Arial" pitchFamily="34" charset="0"/>
+                <a:ea typeface="Arial" pitchFamily="34" charset="-122"/>
+                <a:cs typeface="Arial" pitchFamily="34" charset="-120"/>
+              </a:rPr>
+              <a:t>Sparely</a:t>
+            </a:r>
+            <a:endParaRPr lang="en-US" sz="1500" dirty="0"/>
+          </a:p>
+        </p:txBody>
+      </p:sp>
     </p:spTree>
   </p:cSld>
   <p:clrMapOvr>

</xml_diff>

<commit_message>
Zet het Sparely-logo in de cover-lockup
Co-Authored-By: Claude Fable 5 <noreply@anthropic.com>
Claude-Session: https://claude.ai/code/session_0141FN3f3hHkYQHTyvTJJGrw
</commit_message>
<xml_diff>
--- a/output/LINK. kennismaking Sparely.pptx
+++ b/output/LINK. kennismaking Sparely.pptx
@@ -2626,7 +2626,7 @@
         <p:spPr>
           <a:xfrm>
             <a:off x="1854195" y="5714986"/>
-            <a:ext cx="1396997" cy="406399"/>
+            <a:ext cx="2201328" cy="406399"/>
           </a:xfrm>
           <a:prstGeom prst="roundRect">
             <a:avLst>
@@ -2639,16 +2639,40 @@
           <a:ln/>
         </p:spPr>
       </p:sp>
-      <p:sp>
-        <p:nvSpPr>
-          <p:cNvPr id="33" name="Text 31"/>
-          <p:cNvSpPr txBox="1"/>
-          <p:nvPr/>
-        </p:nvSpPr>
-        <p:spPr>
-          <a:xfrm>
-            <a:off x="1854195" y="5714986"/>
-            <a:ext cx="1396997" cy="406399"/>
+      <p:pic>
+        <p:nvPicPr>
+          <p:cNvPr id="33" name="Image 0" descr="preencoded.png">    </p:cNvPr>
+          <p:cNvPicPr>
+            <a:picLocks noChangeAspect="1"/>
+          </p:cNvPicPr>
+          <p:nvPr/>
+        </p:nvPicPr>
+        <p:blipFill>
+          <a:blip r:embed="rId1"/>
+          <a:stretch>
+            <a:fillRect/>
+          </a:stretch>
+        </p:blipFill>
+        <p:spPr>
+          <a:xfrm>
+            <a:off x="2031995" y="5791186"/>
+            <a:ext cx="232833" cy="253999"/>
+          </a:xfrm>
+          <a:prstGeom prst="rect">
+            <a:avLst/>
+          </a:prstGeom>
+        </p:spPr>
+      </p:pic>
+      <p:sp>
+        <p:nvSpPr>
+          <p:cNvPr id="34" name="Text 31"/>
+          <p:cNvSpPr txBox="1"/>
+          <p:nvPr/>
+        </p:nvSpPr>
+        <p:spPr>
+          <a:xfrm>
+            <a:off x="2366427" y="5714986"/>
+            <a:ext cx="1511296" cy="406399"/>
           </a:xfrm>
           <a:prstGeom prst="rect">
             <a:avLst/>
@@ -2660,7 +2684,7 @@
           <a:bodyPr wrap="square" lIns="0" tIns="0" rIns="0" bIns="0" rtlCol="0" anchor="ctr"/>
           <a:lstStyle/>
           <a:p>
-            <a:pPr algn="ctr" indent="0" marL="0">
+            <a:pPr algn="l" indent="0" marL="0">
               <a:buNone/>
             </a:pPr>
             <a:r>

</xml_diff>

<commit_message>
Voeg vervolgslide toe over hoe de samenwerking na de pilot doorloopt
Nieuwe slide in de drie standaarddecks met het samenwerkingsmodel
zonder bedragen: vaste bezetting, vast target uit de pilot,
doorbellen onder target en een bonus boven target. De prijsbalk
in het aanbod-sjabloon is optioneel gemaakt, zodat dezelfde vier
blokken ook zonder tarieven werken.

Co-Authored-By: Claude Opus 5 <noreply@anthropic.com>
Claude-Session: https://claude.ai/code/session_0141FN3f3hHkYQHTyvTJJGrw
</commit_message>
<xml_diff>
--- a/output/LINK. kennismaking Sparely.pptx
+++ b/output/LINK. kennismaking Sparely.pptx
@@ -15,9 +15,10 @@
     <p:sldId id="263" r:id="rId9"/>
     <p:sldId id="264" r:id="rId10"/>
     <p:sldId id="265" r:id="rId11"/>
+    <p:sldId id="266" r:id="rId12"/>
   </p:sldIdLst>
   <p:notesMasterIdLst>
-    <p:notesMasterId r:id="rId12"/>
+    <p:notesMasterId r:id="rId13"/>
   </p:notesMasterIdLst>
   <p:sldSz cx="12191970" cy="6858000"/>
   <p:notesSz cx="6858000" cy="12191970"/>
@@ -623,6 +624,94 @@
             <a:fld id="{F7021451-1387-4CA6-816F-3879F97B5CBC}" type="slidenum">
               <a:rPr lang="en-US"/>
               <a:t>10</a:t>
+            </a:fld>
+            <a:endParaRPr lang="en-US"/>
+          </a:p>
+        </p:txBody>
+      </p:sp>
+    </p:spTree>
+    <p:extLst>
+      <p:ext uri="{BB962C8B-B14F-4D97-AF65-F5344CB8AC3E}">
+        <p14:creationId xmlns:p14="http://schemas.microsoft.com/office/powerpoint/2010/main" val="1024086991"/>
+      </p:ext>
+    </p:extLst>
+  </p:cSld>
+  <p:clrMapOvr>
+    <a:masterClrMapping/>
+  </p:clrMapOvr>
+</p:notes>
+</file>
+
+<file path=ppt/notesSlides/notesSlide11.xml><?xml version="1.0" encoding="utf-8"?>
+<p:notes xmlns:a="http://schemas.openxmlformats.org/drawingml/2006/main" xmlns:r="http://schemas.openxmlformats.org/officeDocument/2006/relationships" xmlns:p="http://schemas.openxmlformats.org/presentationml/2006/main">
+  <p:cSld>
+    <p:spTree>
+      <p:nvGrpSpPr>
+        <p:cNvPr id="1" name=""/>
+        <p:cNvGrpSpPr/>
+        <p:nvPr/>
+      </p:nvGrpSpPr>
+      <p:grpSpPr>
+        <a:xfrm>
+          <a:off x="0" y="0"/>
+          <a:ext cx="0" cy="0"/>
+          <a:chOff x="0" y="0"/>
+          <a:chExt cx="0" cy="0"/>
+        </a:xfrm>
+      </p:grpSpPr>
+      <p:sp>
+        <p:nvSpPr>
+          <p:cNvPr id="2" name="Slide Image Placeholder 1"/>
+          <p:cNvSpPr>
+            <a:spLocks noGrp="1" noRot="1" noChangeAspect="1"/>
+          </p:cNvSpPr>
+          <p:nvPr>
+            <p:ph type="sldImg"/>
+          </p:nvPr>
+        </p:nvSpPr>
+        <p:spPr/>
+      </p:sp>
+      <p:sp>
+        <p:nvSpPr>
+          <p:cNvPr id="3" name="Notes Placeholder 2"/>
+          <p:cNvSpPr>
+            <a:spLocks noGrp="1"/>
+          </p:cNvSpPr>
+          <p:nvPr>
+            <p:ph type="body" idx="1"/>
+          </p:nvPr>
+        </p:nvSpPr>
+        <p:spPr/>
+        <p:txBody>
+          <a:bodyPr/>
+          <a:lstStyle/>
+          <a:p>
+            <a:r>
+              <a:rPr lang="en-US" dirty="0"/>
+              <a:t/>
+            </a:r>
+            <a:endParaRPr lang="en-US" dirty="0"/>
+          </a:p>
+        </p:txBody>
+      </p:sp>
+      <p:sp>
+        <p:nvSpPr>
+          <p:cNvPr id="4" name="Slide Number Placeholder 3"/>
+          <p:cNvSpPr>
+            <a:spLocks noGrp="1"/>
+          </p:cNvSpPr>
+          <p:nvPr>
+            <p:ph type="sldNum" sz="quarter" idx="10"/>
+          </p:nvPr>
+        </p:nvSpPr>
+        <p:spPr/>
+        <p:txBody>
+          <a:bodyPr/>
+          <a:lstStyle/>
+          <a:p>
+            <a:fld id="{F7021451-1387-4CA6-816F-3879F97B5CBC}" type="slidenum">
+              <a:rPr lang="en-US"/>
+              <a:t>11</a:t>
             </a:fld>
             <a:endParaRPr lang="en-US"/>
           </a:p>
@@ -2362,7 +2451,7 @@
                 <a:ea typeface="Arial" pitchFamily="34" charset="-122"/>
                 <a:cs typeface="Arial" pitchFamily="34" charset="-120"/>
               </a:rPr>
-              <a:t>1 / 10</a:t>
+              <a:t>1 / 11</a:t>
             </a:r>
             <a:endParaRPr lang="en-US" sz="750" dirty="0"/>
           </a:p>
@@ -2626,7 +2715,7 @@
         <p:spPr>
           <a:xfrm>
             <a:off x="1854195" y="5714986"/>
-            <a:ext cx="2201328" cy="406399"/>
+            <a:ext cx="1598079" cy="406399"/>
           </a:xfrm>
           <a:prstGeom prst="roundRect">
             <a:avLst>
@@ -2672,7 +2761,7 @@
         <p:spPr>
           <a:xfrm>
             <a:off x="2366427" y="5714986"/>
-            <a:ext cx="1511296" cy="406399"/>
+            <a:ext cx="908048" cy="406399"/>
           </a:xfrm>
           <a:prstGeom prst="rect">
             <a:avLst/>
@@ -2713,6 +2802,1438 @@
 <file path=ppt/slides/slide10.xml><?xml version="1.0" encoding="utf-8"?>
 <p:sld xmlns:a="http://schemas.openxmlformats.org/drawingml/2006/main" xmlns:r="http://schemas.openxmlformats.org/officeDocument/2006/relationships" xmlns:p="http://schemas.openxmlformats.org/presentationml/2006/main">
   <p:cSld name="Slide 10">
+    <p:bg>
+      <p:bgPr>
+        <a:solidFill>
+          <a:srgbClr val="E9E0CD"/>
+        </a:solidFill>
+      </p:bgPr>
+    </p:bg>
+    <p:spTree>
+      <p:nvGrpSpPr>
+        <p:cNvPr id="1" name=""/>
+        <p:cNvGrpSpPr/>
+        <p:nvPr/>
+      </p:nvGrpSpPr>
+      <p:grpSpPr>
+        <a:xfrm>
+          <a:off x="0" y="0"/>
+          <a:ext cx="0" cy="0"/>
+          <a:chOff x="0" y="0"/>
+          <a:chExt cx="0" cy="0"/>
+        </a:xfrm>
+      </p:grpSpPr>
+      <p:sp>
+        <p:nvSpPr>
+          <p:cNvPr id="2" name="Text 0"/>
+          <p:cNvSpPr txBox="1"/>
+          <p:nvPr/>
+        </p:nvSpPr>
+        <p:spPr>
+          <a:xfrm>
+            <a:off x="596899" y="368299"/>
+            <a:ext cx="1904995" cy="330199"/>
+          </a:xfrm>
+          <a:prstGeom prst="rect">
+            <a:avLst/>
+          </a:prstGeom>
+          <a:noFill/>
+          <a:ln/>
+        </p:spPr>
+        <p:txBody>
+          <a:bodyPr wrap="square" lIns="0" tIns="0" rIns="0" bIns="0" rtlCol="0" anchor="ctr"/>
+          <a:lstStyle/>
+          <a:p>
+            <a:pPr algn="l" indent="0" marL="0">
+              <a:buNone/>
+            </a:pPr>
+            <a:r>
+              <a:rPr lang="en-US" sz="1800" b="1" dirty="0">
+                <a:solidFill>
+                  <a:srgbClr val="1C2230"/>
+                </a:solidFill>
+                <a:latin typeface="Arial" pitchFamily="34" charset="0"/>
+                <a:ea typeface="Arial" pitchFamily="34" charset="-122"/>
+                <a:cs typeface="Arial" pitchFamily="34" charset="-120"/>
+              </a:rPr>
+              <a:t>LINK</a:t>
+            </a:r>
+            <a:pPr algn="l" indent="0" marL="0">
+              <a:buNone/>
+            </a:pPr>
+            <a:r>
+              <a:rPr lang="en-US" sz="1800" b="1" dirty="0">
+                <a:solidFill>
+                  <a:srgbClr val="38B6FF"/>
+                </a:solidFill>
+                <a:latin typeface="Arial" pitchFamily="34" charset="0"/>
+                <a:ea typeface="Arial" pitchFamily="34" charset="-122"/>
+                <a:cs typeface="Arial" pitchFamily="34" charset="-120"/>
+              </a:rPr>
+              <a:t>.</a:t>
+            </a:r>
+            <a:endParaRPr lang="en-US" sz="1800" dirty="0"/>
+          </a:p>
+        </p:txBody>
+      </p:sp>
+      <p:sp>
+        <p:nvSpPr>
+          <p:cNvPr id="3" name="Text 1"/>
+          <p:cNvSpPr txBox="1"/>
+          <p:nvPr/>
+        </p:nvSpPr>
+        <p:spPr>
+          <a:xfrm>
+            <a:off x="609598" y="6381734"/>
+            <a:ext cx="5714986" cy="228599"/>
+          </a:xfrm>
+          <a:prstGeom prst="rect">
+            <a:avLst/>
+          </a:prstGeom>
+          <a:noFill/>
+          <a:ln/>
+        </p:spPr>
+        <p:txBody>
+          <a:bodyPr wrap="square" lIns="0" tIns="0" rIns="0" bIns="0" rtlCol="0" anchor="ctr"/>
+          <a:lstStyle/>
+          <a:p>
+            <a:pPr algn="l" indent="0" marL="0">
+              <a:buNone/>
+            </a:pPr>
+            <a:r>
+              <a:rPr lang="en-US" sz="750" b="1" spc="100" kern="0" dirty="0">
+                <a:solidFill>
+                  <a:srgbClr val="6F6A5C"/>
+                </a:solidFill>
+                <a:latin typeface="Arial" pitchFamily="34" charset="0"/>
+                <a:ea typeface="Arial" pitchFamily="34" charset="-122"/>
+                <a:cs typeface="Arial" pitchFamily="34" charset="-120"/>
+              </a:rPr>
+              <a:t>LINK. · Kennismaking Sparely</a:t>
+            </a:r>
+            <a:endParaRPr lang="en-US" sz="750" dirty="0"/>
+          </a:p>
+        </p:txBody>
+      </p:sp>
+      <p:sp>
+        <p:nvSpPr>
+          <p:cNvPr id="4" name="Text 2"/>
+          <p:cNvSpPr txBox="1"/>
+          <p:nvPr/>
+        </p:nvSpPr>
+        <p:spPr>
+          <a:xfrm>
+            <a:off x="9677376" y="6381734"/>
+            <a:ext cx="1904995" cy="228599"/>
+          </a:xfrm>
+          <a:prstGeom prst="rect">
+            <a:avLst/>
+          </a:prstGeom>
+          <a:noFill/>
+          <a:ln/>
+        </p:spPr>
+        <p:txBody>
+          <a:bodyPr wrap="square" lIns="0" tIns="0" rIns="0" bIns="0" rtlCol="0" anchor="ctr"/>
+          <a:lstStyle/>
+          <a:p>
+            <a:pPr algn="r" indent="0" marL="0">
+              <a:buNone/>
+            </a:pPr>
+            <a:r>
+              <a:rPr lang="en-US" sz="750" b="1" spc="100" kern="0" dirty="0">
+                <a:solidFill>
+                  <a:srgbClr val="6F6A5C"/>
+                </a:solidFill>
+                <a:latin typeface="Arial" pitchFamily="34" charset="0"/>
+                <a:ea typeface="Arial" pitchFamily="34" charset="-122"/>
+                <a:cs typeface="Arial" pitchFamily="34" charset="-120"/>
+              </a:rPr>
+              <a:t>10 / 11</a:t>
+            </a:r>
+            <a:endParaRPr lang="en-US" sz="750" dirty="0"/>
+          </a:p>
+        </p:txBody>
+      </p:sp>
+      <p:sp>
+        <p:nvSpPr>
+          <p:cNvPr id="5" name="Text 3"/>
+          <p:cNvSpPr txBox="1"/>
+          <p:nvPr/>
+        </p:nvSpPr>
+        <p:spPr>
+          <a:xfrm>
+            <a:off x="609598" y="1206497"/>
+            <a:ext cx="10159975" cy="215899"/>
+          </a:xfrm>
+          <a:prstGeom prst="rect">
+            <a:avLst/>
+          </a:prstGeom>
+          <a:noFill/>
+          <a:ln/>
+        </p:spPr>
+        <p:txBody>
+          <a:bodyPr wrap="square" lIns="0" tIns="0" rIns="0" bIns="0" rtlCol="0" anchor="ctr"/>
+          <a:lstStyle/>
+          <a:p>
+            <a:pPr algn="l" indent="0" marL="0">
+              <a:buNone/>
+            </a:pPr>
+            <a:r>
+              <a:rPr lang="en-US" sz="950" b="1" spc="400" kern="0" dirty="0">
+                <a:solidFill>
+                  <a:srgbClr val="38B6FF"/>
+                </a:solidFill>
+                <a:latin typeface="Arial" pitchFamily="34" charset="0"/>
+                <a:ea typeface="Arial" pitchFamily="34" charset="-122"/>
+                <a:cs typeface="Arial" pitchFamily="34" charset="-120"/>
+              </a:rPr>
+              <a:t>SPELREGELS</a:t>
+            </a:r>
+            <a:endParaRPr lang="en-US" sz="950" dirty="0"/>
+          </a:p>
+        </p:txBody>
+      </p:sp>
+      <p:sp>
+        <p:nvSpPr>
+          <p:cNvPr id="6" name="Text 4"/>
+          <p:cNvSpPr txBox="1"/>
+          <p:nvPr/>
+        </p:nvSpPr>
+        <p:spPr>
+          <a:xfrm>
+            <a:off x="609598" y="1511296"/>
+            <a:ext cx="10972773" cy="1142997"/>
+          </a:xfrm>
+          <a:prstGeom prst="rect">
+            <a:avLst/>
+          </a:prstGeom>
+          <a:noFill/>
+          <a:ln/>
+        </p:spPr>
+        <p:txBody>
+          <a:bodyPr wrap="square" lIns="0" tIns="0" rIns="0" bIns="0" rtlCol="0" anchor="t"/>
+          <a:lstStyle/>
+          <a:p>
+            <a:pPr algn="l" indent="0" marL="0">
+              <a:lnSpc>
+                <a:spcPct val="108000"/>
+              </a:lnSpc>
+              <a:buNone/>
+            </a:pPr>
+            <a:r>
+              <a:rPr lang="en-US" sz="3200" b="1" dirty="0">
+                <a:solidFill>
+                  <a:srgbClr val="1C2230"/>
+                </a:solidFill>
+                <a:latin typeface="Arial" pitchFamily="34" charset="0"/>
+                <a:ea typeface="Arial" pitchFamily="34" charset="-122"/>
+                <a:cs typeface="Arial" pitchFamily="34" charset="-120"/>
+              </a:rPr>
+              <a:t>Transparant en zonder </a:t>
+            </a:r>
+            <a:pPr algn="l" indent="0" marL="0">
+              <a:lnSpc>
+                <a:spcPct val="108000"/>
+              </a:lnSpc>
+              <a:buNone/>
+            </a:pPr>
+            <a:r>
+              <a:rPr lang="en-US" sz="3000" i="1" dirty="0">
+                <a:solidFill>
+                  <a:srgbClr val="1C2230"/>
+                </a:solidFill>
+                <a:latin typeface="Georgia" pitchFamily="34" charset="0"/>
+                <a:ea typeface="Georgia" pitchFamily="34" charset="-122"/>
+                <a:cs typeface="Georgia" pitchFamily="34" charset="-120"/>
+              </a:rPr>
+              <a:t>kleine lettertjes</a:t>
+            </a:r>
+            <a:pPr algn="l" indent="0" marL="0">
+              <a:lnSpc>
+                <a:spcPct val="108000"/>
+              </a:lnSpc>
+              <a:buNone/>
+            </a:pPr>
+            <a:r>
+              <a:rPr lang="en-US" sz="3200" b="1" dirty="0">
+                <a:solidFill>
+                  <a:srgbClr val="1C2230"/>
+                </a:solidFill>
+                <a:latin typeface="Arial" pitchFamily="34" charset="0"/>
+                <a:ea typeface="Arial" pitchFamily="34" charset="-122"/>
+                <a:cs typeface="Arial" pitchFamily="34" charset="-120"/>
+              </a:rPr>
+              <a:t>.</a:t>
+            </a:r>
+            <a:endParaRPr lang="en-US" sz="3200" dirty="0"/>
+          </a:p>
+        </p:txBody>
+      </p:sp>
+      <p:sp>
+        <p:nvSpPr>
+          <p:cNvPr id="7" name="Shape 5"/>
+          <p:cNvSpPr/>
+          <p:nvPr/>
+        </p:nvSpPr>
+        <p:spPr>
+          <a:xfrm>
+            <a:off x="609598" y="2819393"/>
+            <a:ext cx="253999" cy="253999"/>
+          </a:xfrm>
+          <a:prstGeom prst="roundRect">
+            <a:avLst>
+              <a:gd name="adj" fmla="val 25000"/>
+            </a:avLst>
+          </a:prstGeom>
+          <a:solidFill>
+            <a:srgbClr val="DDEBF3"/>
+          </a:solidFill>
+          <a:ln/>
+        </p:spPr>
+      </p:sp>
+      <p:pic>
+        <p:nvPicPr>
+          <p:cNvPr id="8" name="Image 0" descr="preencoded.png">    </p:cNvPr>
+          <p:cNvPicPr>
+            <a:picLocks noChangeAspect="1"/>
+          </p:cNvPicPr>
+          <p:nvPr/>
+        </p:nvPicPr>
+        <p:blipFill>
+          <a:blip r:embed="rId1"/>
+          <a:stretch>
+            <a:fillRect/>
+          </a:stretch>
+        </p:blipFill>
+        <p:spPr>
+          <a:xfrm>
+            <a:off x="666748" y="2876543"/>
+            <a:ext cx="139700" cy="139700"/>
+          </a:xfrm>
+          <a:prstGeom prst="rect">
+            <a:avLst/>
+          </a:prstGeom>
+        </p:spPr>
+      </p:pic>
+      <p:sp>
+        <p:nvSpPr>
+          <p:cNvPr id="9" name="Text 6"/>
+          <p:cNvSpPr txBox="1"/>
+          <p:nvPr/>
+        </p:nvSpPr>
+        <p:spPr>
+          <a:xfrm>
+            <a:off x="1015997" y="2793993"/>
+            <a:ext cx="4825988" cy="228599"/>
+          </a:xfrm>
+          <a:prstGeom prst="rect">
+            <a:avLst/>
+          </a:prstGeom>
+          <a:noFill/>
+          <a:ln/>
+        </p:spPr>
+        <p:txBody>
+          <a:bodyPr wrap="square" lIns="0" tIns="0" rIns="0" bIns="0" rtlCol="0" anchor="ctr"/>
+          <a:lstStyle/>
+          <a:p>
+            <a:pPr indent="0" marL="0">
+              <a:buNone/>
+            </a:pPr>
+            <a:r>
+              <a:rPr lang="en-US" sz="1200" b="1" dirty="0">
+                <a:solidFill>
+                  <a:srgbClr val="1C2230"/>
+                </a:solidFill>
+                <a:latin typeface="Arial" pitchFamily="34" charset="0"/>
+                <a:ea typeface="Arial" pitchFamily="34" charset="-122"/>
+                <a:cs typeface="Arial" pitchFamily="34" charset="-120"/>
+              </a:rPr>
+              <a:t>Niet-exclusief</a:t>
+            </a:r>
+            <a:endParaRPr lang="en-US" sz="1200" dirty="0"/>
+          </a:p>
+        </p:txBody>
+      </p:sp>
+      <p:sp>
+        <p:nvSpPr>
+          <p:cNvPr id="10" name="Text 7"/>
+          <p:cNvSpPr txBox="1"/>
+          <p:nvPr/>
+        </p:nvSpPr>
+        <p:spPr>
+          <a:xfrm>
+            <a:off x="1015997" y="3035292"/>
+            <a:ext cx="4825988" cy="355599"/>
+          </a:xfrm>
+          <a:prstGeom prst="rect">
+            <a:avLst/>
+          </a:prstGeom>
+          <a:noFill/>
+          <a:ln/>
+        </p:spPr>
+        <p:txBody>
+          <a:bodyPr wrap="square" lIns="0" tIns="0" rIns="0" bIns="0" rtlCol="0" anchor="t"/>
+          <a:lstStyle/>
+          <a:p>
+            <a:pPr indent="0" marL="0">
+              <a:lnSpc>
+                <a:spcPct val="130000"/>
+              </a:lnSpc>
+              <a:buNone/>
+            </a:pPr>
+            <a:r>
+              <a:rPr lang="en-US" sz="950" dirty="0">
+                <a:solidFill>
+                  <a:srgbClr val="6F6A5C"/>
+                </a:solidFill>
+                <a:latin typeface="Arial" pitchFamily="34" charset="0"/>
+                <a:ea typeface="Arial" pitchFamily="34" charset="-122"/>
+                <a:cs typeface="Arial" pitchFamily="34" charset="-120"/>
+              </a:rPr>
+              <a:t>Jullie zitten nergens aan vast en houden alle vrijheid.</a:t>
+            </a:r>
+            <a:endParaRPr lang="en-US" sz="950" dirty="0"/>
+          </a:p>
+        </p:txBody>
+      </p:sp>
+      <p:sp>
+        <p:nvSpPr>
+          <p:cNvPr id="11" name="Shape 8"/>
+          <p:cNvSpPr/>
+          <p:nvPr/>
+        </p:nvSpPr>
+        <p:spPr>
+          <a:xfrm>
+            <a:off x="6349984" y="2819393"/>
+            <a:ext cx="253999" cy="253999"/>
+          </a:xfrm>
+          <a:prstGeom prst="roundRect">
+            <a:avLst>
+              <a:gd name="adj" fmla="val 25000"/>
+            </a:avLst>
+          </a:prstGeom>
+          <a:solidFill>
+            <a:srgbClr val="DDEBF3"/>
+          </a:solidFill>
+          <a:ln/>
+        </p:spPr>
+      </p:sp>
+      <p:pic>
+        <p:nvPicPr>
+          <p:cNvPr id="12" name="Image 1" descr="preencoded.png">    </p:cNvPr>
+          <p:cNvPicPr>
+            <a:picLocks noChangeAspect="1"/>
+          </p:cNvPicPr>
+          <p:nvPr/>
+        </p:nvPicPr>
+        <p:blipFill>
+          <a:blip r:embed="rId2"/>
+          <a:stretch>
+            <a:fillRect/>
+          </a:stretch>
+        </p:blipFill>
+        <p:spPr>
+          <a:xfrm>
+            <a:off x="6407134" y="2876543"/>
+            <a:ext cx="139700" cy="139700"/>
+          </a:xfrm>
+          <a:prstGeom prst="rect">
+            <a:avLst/>
+          </a:prstGeom>
+        </p:spPr>
+      </p:pic>
+      <p:sp>
+        <p:nvSpPr>
+          <p:cNvPr id="13" name="Text 9"/>
+          <p:cNvSpPr txBox="1"/>
+          <p:nvPr/>
+        </p:nvSpPr>
+        <p:spPr>
+          <a:xfrm>
+            <a:off x="6756383" y="2793993"/>
+            <a:ext cx="4825988" cy="228599"/>
+          </a:xfrm>
+          <a:prstGeom prst="rect">
+            <a:avLst/>
+          </a:prstGeom>
+          <a:noFill/>
+          <a:ln/>
+        </p:spPr>
+        <p:txBody>
+          <a:bodyPr wrap="square" lIns="0" tIns="0" rIns="0" bIns="0" rtlCol="0" anchor="ctr"/>
+          <a:lstStyle/>
+          <a:p>
+            <a:pPr indent="0" marL="0">
+              <a:buNone/>
+            </a:pPr>
+            <a:r>
+              <a:rPr lang="en-US" sz="1200" b="1" dirty="0">
+                <a:solidFill>
+                  <a:srgbClr val="1C2230"/>
+                </a:solidFill>
+                <a:latin typeface="Arial" pitchFamily="34" charset="0"/>
+                <a:ea typeface="Arial" pitchFamily="34" charset="-122"/>
+                <a:cs typeface="Arial" pitchFamily="34" charset="-120"/>
+              </a:rPr>
+              <a:t>Bestaande relaties blijven van jullie</a:t>
+            </a:r>
+            <a:endParaRPr lang="en-US" sz="1200" dirty="0"/>
+          </a:p>
+        </p:txBody>
+      </p:sp>
+      <p:sp>
+        <p:nvSpPr>
+          <p:cNvPr id="14" name="Text 10"/>
+          <p:cNvSpPr txBox="1"/>
+          <p:nvPr/>
+        </p:nvSpPr>
+        <p:spPr>
+          <a:xfrm>
+            <a:off x="6756383" y="3035292"/>
+            <a:ext cx="4825988" cy="355599"/>
+          </a:xfrm>
+          <a:prstGeom prst="rect">
+            <a:avLst/>
+          </a:prstGeom>
+          <a:noFill/>
+          <a:ln/>
+        </p:spPr>
+        <p:txBody>
+          <a:bodyPr wrap="square" lIns="0" tIns="0" rIns="0" bIns="0" rtlCol="0" anchor="t"/>
+          <a:lstStyle/>
+          <a:p>
+            <a:pPr indent="0" marL="0">
+              <a:lnSpc>
+                <a:spcPct val="130000"/>
+              </a:lnSpc>
+              <a:buNone/>
+            </a:pPr>
+            <a:r>
+              <a:rPr lang="en-US" sz="950" dirty="0">
+                <a:solidFill>
+                  <a:srgbClr val="6F6A5C"/>
+                </a:solidFill>
+                <a:latin typeface="Arial" pitchFamily="34" charset="0"/>
+                <a:ea typeface="Arial" pitchFamily="34" charset="-122"/>
+                <a:cs typeface="Arial" pitchFamily="34" charset="-120"/>
+              </a:rPr>
+              <a:t>Uitsluitlijst vooraf, die bedrijven benaderen wij niet.</a:t>
+            </a:r>
+            <a:endParaRPr lang="en-US" sz="950" dirty="0"/>
+          </a:p>
+        </p:txBody>
+      </p:sp>
+      <p:sp>
+        <p:nvSpPr>
+          <p:cNvPr id="15" name="Shape 11"/>
+          <p:cNvSpPr/>
+          <p:nvPr/>
+        </p:nvSpPr>
+        <p:spPr>
+          <a:xfrm>
+            <a:off x="609598" y="3428991"/>
+            <a:ext cx="5232387" cy="0"/>
+          </a:xfrm>
+          <a:prstGeom prst="line">
+            <a:avLst/>
+          </a:prstGeom>
+          <a:noFill/>
+          <a:ln w="6350">
+            <a:solidFill>
+              <a:srgbClr val="C9C2B2"/>
+            </a:solidFill>
+            <a:prstDash val="solid"/>
+          </a:ln>
+        </p:spPr>
+      </p:sp>
+      <p:sp>
+        <p:nvSpPr>
+          <p:cNvPr id="16" name="Shape 12"/>
+          <p:cNvSpPr/>
+          <p:nvPr/>
+        </p:nvSpPr>
+        <p:spPr>
+          <a:xfrm>
+            <a:off x="609598" y="3530591"/>
+            <a:ext cx="253999" cy="253999"/>
+          </a:xfrm>
+          <a:prstGeom prst="roundRect">
+            <a:avLst>
+              <a:gd name="adj" fmla="val 25000"/>
+            </a:avLst>
+          </a:prstGeom>
+          <a:solidFill>
+            <a:srgbClr val="DDEBF3"/>
+          </a:solidFill>
+          <a:ln/>
+        </p:spPr>
+      </p:sp>
+      <p:pic>
+        <p:nvPicPr>
+          <p:cNvPr id="17" name="Image 2" descr="preencoded.png">    </p:cNvPr>
+          <p:cNvPicPr>
+            <a:picLocks noChangeAspect="1"/>
+          </p:cNvPicPr>
+          <p:nvPr/>
+        </p:nvPicPr>
+        <p:blipFill>
+          <a:blip r:embed="rId3"/>
+          <a:stretch>
+            <a:fillRect/>
+          </a:stretch>
+        </p:blipFill>
+        <p:spPr>
+          <a:xfrm>
+            <a:off x="666748" y="3587741"/>
+            <a:ext cx="139700" cy="139700"/>
+          </a:xfrm>
+          <a:prstGeom prst="rect">
+            <a:avLst/>
+          </a:prstGeom>
+        </p:spPr>
+      </p:pic>
+      <p:sp>
+        <p:nvSpPr>
+          <p:cNvPr id="18" name="Text 13"/>
+          <p:cNvSpPr txBox="1"/>
+          <p:nvPr/>
+        </p:nvSpPr>
+        <p:spPr>
+          <a:xfrm>
+            <a:off x="1015997" y="3505191"/>
+            <a:ext cx="4825988" cy="228599"/>
+          </a:xfrm>
+          <a:prstGeom prst="rect">
+            <a:avLst/>
+          </a:prstGeom>
+          <a:noFill/>
+          <a:ln/>
+        </p:spPr>
+        <p:txBody>
+          <a:bodyPr wrap="square" lIns="0" tIns="0" rIns="0" bIns="0" rtlCol="0" anchor="ctr"/>
+          <a:lstStyle/>
+          <a:p>
+            <a:pPr indent="0" marL="0">
+              <a:buNone/>
+            </a:pPr>
+            <a:r>
+              <a:rPr lang="en-US" sz="1200" b="1" dirty="0">
+                <a:solidFill>
+                  <a:srgbClr val="1C2230"/>
+                </a:solidFill>
+                <a:latin typeface="Arial" pitchFamily="34" charset="0"/>
+                <a:ea typeface="Arial" pitchFamily="34" charset="-122"/>
+                <a:cs typeface="Arial" pitchFamily="34" charset="-120"/>
+              </a:rPr>
+              <a:t>Werkperiodes van 4 weken</a:t>
+            </a:r>
+            <a:endParaRPr lang="en-US" sz="1200" dirty="0"/>
+          </a:p>
+        </p:txBody>
+      </p:sp>
+      <p:sp>
+        <p:nvSpPr>
+          <p:cNvPr id="19" name="Text 14"/>
+          <p:cNvSpPr txBox="1"/>
+          <p:nvPr/>
+        </p:nvSpPr>
+        <p:spPr>
+          <a:xfrm>
+            <a:off x="1015997" y="3746491"/>
+            <a:ext cx="4825988" cy="355599"/>
+          </a:xfrm>
+          <a:prstGeom prst="rect">
+            <a:avLst/>
+          </a:prstGeom>
+          <a:noFill/>
+          <a:ln/>
+        </p:spPr>
+        <p:txBody>
+          <a:bodyPr wrap="square" lIns="0" tIns="0" rIns="0" bIns="0" rtlCol="0" anchor="t"/>
+          <a:lstStyle/>
+          <a:p>
+            <a:pPr indent="0" marL="0">
+              <a:lnSpc>
+                <a:spcPct val="130000"/>
+              </a:lnSpc>
+              <a:buNone/>
+            </a:pPr>
+            <a:r>
+              <a:rPr lang="en-US" sz="950" dirty="0">
+                <a:solidFill>
+                  <a:srgbClr val="6F6A5C"/>
+                </a:solidFill>
+                <a:latin typeface="Arial" pitchFamily="34" charset="0"/>
+                <a:ea typeface="Arial" pitchFamily="34" charset="-122"/>
+                <a:cs typeface="Arial" pitchFamily="34" charset="-120"/>
+              </a:rPr>
+              <a:t>Vooraf gefactureerd, per werkperiode.</a:t>
+            </a:r>
+            <a:endParaRPr lang="en-US" sz="950" dirty="0"/>
+          </a:p>
+        </p:txBody>
+      </p:sp>
+      <p:sp>
+        <p:nvSpPr>
+          <p:cNvPr id="20" name="Shape 15"/>
+          <p:cNvSpPr/>
+          <p:nvPr/>
+        </p:nvSpPr>
+        <p:spPr>
+          <a:xfrm>
+            <a:off x="6349984" y="3428991"/>
+            <a:ext cx="5232387" cy="0"/>
+          </a:xfrm>
+          <a:prstGeom prst="line">
+            <a:avLst/>
+          </a:prstGeom>
+          <a:noFill/>
+          <a:ln w="6350">
+            <a:solidFill>
+              <a:srgbClr val="C9C2B2"/>
+            </a:solidFill>
+            <a:prstDash val="solid"/>
+          </a:ln>
+        </p:spPr>
+      </p:sp>
+      <p:sp>
+        <p:nvSpPr>
+          <p:cNvPr id="21" name="Shape 16"/>
+          <p:cNvSpPr/>
+          <p:nvPr/>
+        </p:nvSpPr>
+        <p:spPr>
+          <a:xfrm>
+            <a:off x="6349984" y="3530591"/>
+            <a:ext cx="253999" cy="253999"/>
+          </a:xfrm>
+          <a:prstGeom prst="roundRect">
+            <a:avLst>
+              <a:gd name="adj" fmla="val 25000"/>
+            </a:avLst>
+          </a:prstGeom>
+          <a:solidFill>
+            <a:srgbClr val="DDEBF3"/>
+          </a:solidFill>
+          <a:ln/>
+        </p:spPr>
+      </p:sp>
+      <p:pic>
+        <p:nvPicPr>
+          <p:cNvPr id="22" name="Image 3" descr="preencoded.png">    </p:cNvPr>
+          <p:cNvPicPr>
+            <a:picLocks noChangeAspect="1"/>
+          </p:cNvPicPr>
+          <p:nvPr/>
+        </p:nvPicPr>
+        <p:blipFill>
+          <a:blip r:embed="rId4"/>
+          <a:stretch>
+            <a:fillRect/>
+          </a:stretch>
+        </p:blipFill>
+        <p:spPr>
+          <a:xfrm>
+            <a:off x="6407134" y="3587741"/>
+            <a:ext cx="139700" cy="139700"/>
+          </a:xfrm>
+          <a:prstGeom prst="rect">
+            <a:avLst/>
+          </a:prstGeom>
+        </p:spPr>
+      </p:pic>
+      <p:sp>
+        <p:nvSpPr>
+          <p:cNvPr id="23" name="Text 17"/>
+          <p:cNvSpPr txBox="1"/>
+          <p:nvPr/>
+        </p:nvSpPr>
+        <p:spPr>
+          <a:xfrm>
+            <a:off x="6756383" y="3505191"/>
+            <a:ext cx="4825988" cy="228599"/>
+          </a:xfrm>
+          <a:prstGeom prst="rect">
+            <a:avLst/>
+          </a:prstGeom>
+          <a:noFill/>
+          <a:ln/>
+        </p:spPr>
+        <p:txBody>
+          <a:bodyPr wrap="square" lIns="0" tIns="0" rIns="0" bIns="0" rtlCol="0" anchor="ctr"/>
+          <a:lstStyle/>
+          <a:p>
+            <a:pPr indent="0" marL="0">
+              <a:buNone/>
+            </a:pPr>
+            <a:r>
+              <a:rPr lang="en-US" sz="1200" b="1" dirty="0">
+                <a:solidFill>
+                  <a:srgbClr val="1C2230"/>
+                </a:solidFill>
+                <a:latin typeface="Arial" pitchFamily="34" charset="0"/>
+                <a:ea typeface="Arial" pitchFamily="34" charset="-122"/>
+                <a:cs typeface="Arial" pitchFamily="34" charset="-120"/>
+              </a:rPr>
+              <a:t>Wekelijkse rapportage</a:t>
+            </a:r>
+            <a:endParaRPr lang="en-US" sz="1200" dirty="0"/>
+          </a:p>
+        </p:txBody>
+      </p:sp>
+      <p:sp>
+        <p:nvSpPr>
+          <p:cNvPr id="24" name="Text 18"/>
+          <p:cNvSpPr txBox="1"/>
+          <p:nvPr/>
+        </p:nvSpPr>
+        <p:spPr>
+          <a:xfrm>
+            <a:off x="6756383" y="3746491"/>
+            <a:ext cx="4825988" cy="355599"/>
+          </a:xfrm>
+          <a:prstGeom prst="rect">
+            <a:avLst/>
+          </a:prstGeom>
+          <a:noFill/>
+          <a:ln/>
+        </p:spPr>
+        <p:txBody>
+          <a:bodyPr wrap="square" lIns="0" tIns="0" rIns="0" bIns="0" rtlCol="0" anchor="t"/>
+          <a:lstStyle/>
+          <a:p>
+            <a:pPr indent="0" marL="0">
+              <a:lnSpc>
+                <a:spcPct val="130000"/>
+              </a:lnSpc>
+              <a:buNone/>
+            </a:pPr>
+            <a:r>
+              <a:rPr lang="en-US" sz="950" dirty="0">
+                <a:solidFill>
+                  <a:srgbClr val="6F6A5C"/>
+                </a:solidFill>
+                <a:latin typeface="Arial" pitchFamily="34" charset="0"/>
+                <a:ea typeface="Arial" pitchFamily="34" charset="-122"/>
+                <a:cs typeface="Arial" pitchFamily="34" charset="-120"/>
+              </a:rPr>
+              <a:t>Elke week zicht op wat er gebeurd is en wat het opleverde.</a:t>
+            </a:r>
+            <a:endParaRPr lang="en-US" sz="950" dirty="0"/>
+          </a:p>
+        </p:txBody>
+      </p:sp>
+      <p:sp>
+        <p:nvSpPr>
+          <p:cNvPr id="25" name="Shape 19"/>
+          <p:cNvSpPr/>
+          <p:nvPr/>
+        </p:nvSpPr>
+        <p:spPr>
+          <a:xfrm>
+            <a:off x="609598" y="4140190"/>
+            <a:ext cx="5232387" cy="0"/>
+          </a:xfrm>
+          <a:prstGeom prst="line">
+            <a:avLst/>
+          </a:prstGeom>
+          <a:noFill/>
+          <a:ln w="6350">
+            <a:solidFill>
+              <a:srgbClr val="C9C2B2"/>
+            </a:solidFill>
+            <a:prstDash val="solid"/>
+          </a:ln>
+        </p:spPr>
+      </p:sp>
+      <p:sp>
+        <p:nvSpPr>
+          <p:cNvPr id="26" name="Shape 20"/>
+          <p:cNvSpPr/>
+          <p:nvPr/>
+        </p:nvSpPr>
+        <p:spPr>
+          <a:xfrm>
+            <a:off x="609598" y="4241789"/>
+            <a:ext cx="253999" cy="253999"/>
+          </a:xfrm>
+          <a:prstGeom prst="roundRect">
+            <a:avLst>
+              <a:gd name="adj" fmla="val 25000"/>
+            </a:avLst>
+          </a:prstGeom>
+          <a:solidFill>
+            <a:srgbClr val="DDEBF3"/>
+          </a:solidFill>
+          <a:ln/>
+        </p:spPr>
+      </p:sp>
+      <p:pic>
+        <p:nvPicPr>
+          <p:cNvPr id="27" name="Image 4" descr="preencoded.png">    </p:cNvPr>
+          <p:cNvPicPr>
+            <a:picLocks noChangeAspect="1"/>
+          </p:cNvPicPr>
+          <p:nvPr/>
+        </p:nvPicPr>
+        <p:blipFill>
+          <a:blip r:embed="rId5"/>
+          <a:stretch>
+            <a:fillRect/>
+          </a:stretch>
+        </p:blipFill>
+        <p:spPr>
+          <a:xfrm>
+            <a:off x="666748" y="4298939"/>
+            <a:ext cx="139700" cy="139700"/>
+          </a:xfrm>
+          <a:prstGeom prst="rect">
+            <a:avLst/>
+          </a:prstGeom>
+        </p:spPr>
+      </p:pic>
+      <p:sp>
+        <p:nvSpPr>
+          <p:cNvPr id="28" name="Text 21"/>
+          <p:cNvSpPr txBox="1"/>
+          <p:nvPr/>
+        </p:nvSpPr>
+        <p:spPr>
+          <a:xfrm>
+            <a:off x="1015997" y="4216389"/>
+            <a:ext cx="4825988" cy="228599"/>
+          </a:xfrm>
+          <a:prstGeom prst="rect">
+            <a:avLst/>
+          </a:prstGeom>
+          <a:noFill/>
+          <a:ln/>
+        </p:spPr>
+        <p:txBody>
+          <a:bodyPr wrap="square" lIns="0" tIns="0" rIns="0" bIns="0" rtlCol="0" anchor="ctr"/>
+          <a:lstStyle/>
+          <a:p>
+            <a:pPr indent="0" marL="0">
+              <a:buNone/>
+            </a:pPr>
+            <a:r>
+              <a:rPr lang="en-US" sz="1200" b="1" dirty="0">
+                <a:solidFill>
+                  <a:srgbClr val="1C2230"/>
+                </a:solidFill>
+                <a:latin typeface="Arial" pitchFamily="34" charset="0"/>
+                <a:ea typeface="Arial" pitchFamily="34" charset="-122"/>
+                <a:cs typeface="Arial" pitchFamily="34" charset="-120"/>
+              </a:rPr>
+              <a:t>Jullie naam, onze uitvoering</a:t>
+            </a:r>
+            <a:endParaRPr lang="en-US" sz="1200" dirty="0"/>
+          </a:p>
+        </p:txBody>
+      </p:sp>
+      <p:sp>
+        <p:nvSpPr>
+          <p:cNvPr id="29" name="Text 22"/>
+          <p:cNvSpPr txBox="1"/>
+          <p:nvPr/>
+        </p:nvSpPr>
+        <p:spPr>
+          <a:xfrm>
+            <a:off x="1015997" y="4457689"/>
+            <a:ext cx="4825988" cy="355599"/>
+          </a:xfrm>
+          <a:prstGeom prst="rect">
+            <a:avLst/>
+          </a:prstGeom>
+          <a:noFill/>
+          <a:ln/>
+        </p:spPr>
+        <p:txBody>
+          <a:bodyPr wrap="square" lIns="0" tIns="0" rIns="0" bIns="0" rtlCol="0" anchor="t"/>
+          <a:lstStyle/>
+          <a:p>
+            <a:pPr indent="0" marL="0">
+              <a:lnSpc>
+                <a:spcPct val="130000"/>
+              </a:lnSpc>
+              <a:buNone/>
+            </a:pPr>
+            <a:r>
+              <a:rPr lang="en-US" sz="950" dirty="0">
+                <a:solidFill>
+                  <a:srgbClr val="6F6A5C"/>
+                </a:solidFill>
+                <a:latin typeface="Arial" pitchFamily="34" charset="0"/>
+                <a:ea typeface="Arial" pitchFamily="34" charset="-122"/>
+                <a:cs typeface="Arial" pitchFamily="34" charset="-120"/>
+              </a:rPr>
+              <a:t>Regionaal nummer en jullie stijl, wij voeren uit.</a:t>
+            </a:r>
+            <a:endParaRPr lang="en-US" sz="950" dirty="0"/>
+          </a:p>
+        </p:txBody>
+      </p:sp>
+      <p:sp>
+        <p:nvSpPr>
+          <p:cNvPr id="30" name="Shape 23"/>
+          <p:cNvSpPr/>
+          <p:nvPr/>
+        </p:nvSpPr>
+        <p:spPr>
+          <a:xfrm>
+            <a:off x="6349984" y="4140190"/>
+            <a:ext cx="5232387" cy="0"/>
+          </a:xfrm>
+          <a:prstGeom prst="line">
+            <a:avLst/>
+          </a:prstGeom>
+          <a:noFill/>
+          <a:ln w="6350">
+            <a:solidFill>
+              <a:srgbClr val="C9C2B2"/>
+            </a:solidFill>
+            <a:prstDash val="solid"/>
+          </a:ln>
+        </p:spPr>
+      </p:sp>
+      <p:sp>
+        <p:nvSpPr>
+          <p:cNvPr id="31" name="Shape 24"/>
+          <p:cNvSpPr/>
+          <p:nvPr/>
+        </p:nvSpPr>
+        <p:spPr>
+          <a:xfrm>
+            <a:off x="6349984" y="4241789"/>
+            <a:ext cx="253999" cy="253999"/>
+          </a:xfrm>
+          <a:prstGeom prst="roundRect">
+            <a:avLst>
+              <a:gd name="adj" fmla="val 25000"/>
+            </a:avLst>
+          </a:prstGeom>
+          <a:solidFill>
+            <a:srgbClr val="DDEBF3"/>
+          </a:solidFill>
+          <a:ln/>
+        </p:spPr>
+      </p:sp>
+      <p:pic>
+        <p:nvPicPr>
+          <p:cNvPr id="32" name="Image 5" descr="preencoded.png">    </p:cNvPr>
+          <p:cNvPicPr>
+            <a:picLocks noChangeAspect="1"/>
+          </p:cNvPicPr>
+          <p:nvPr/>
+        </p:nvPicPr>
+        <p:blipFill>
+          <a:blip r:embed="rId6"/>
+          <a:stretch>
+            <a:fillRect/>
+          </a:stretch>
+        </p:blipFill>
+        <p:spPr>
+          <a:xfrm>
+            <a:off x="6407134" y="4298939"/>
+            <a:ext cx="139700" cy="139700"/>
+          </a:xfrm>
+          <a:prstGeom prst="rect">
+            <a:avLst/>
+          </a:prstGeom>
+        </p:spPr>
+      </p:pic>
+      <p:sp>
+        <p:nvSpPr>
+          <p:cNvPr id="33" name="Text 25"/>
+          <p:cNvSpPr txBox="1"/>
+          <p:nvPr/>
+        </p:nvSpPr>
+        <p:spPr>
+          <a:xfrm>
+            <a:off x="6756383" y="4216389"/>
+            <a:ext cx="4825988" cy="228599"/>
+          </a:xfrm>
+          <a:prstGeom prst="rect">
+            <a:avLst/>
+          </a:prstGeom>
+          <a:noFill/>
+          <a:ln/>
+        </p:spPr>
+        <p:txBody>
+          <a:bodyPr wrap="square" lIns="0" tIns="0" rIns="0" bIns="0" rtlCol="0" anchor="ctr"/>
+          <a:lstStyle/>
+          <a:p>
+            <a:pPr indent="0" marL="0">
+              <a:buNone/>
+            </a:pPr>
+            <a:r>
+              <a:rPr lang="en-US" sz="1200" b="1" dirty="0">
+                <a:solidFill>
+                  <a:srgbClr val="1C2230"/>
+                </a:solidFill>
+                <a:latin typeface="Arial" pitchFamily="34" charset="0"/>
+                <a:ea typeface="Arial" pitchFamily="34" charset="-122"/>
+                <a:cs typeface="Arial" pitchFamily="34" charset="-120"/>
+              </a:rPr>
+              <a:t>Gegevens veilig</a:t>
+            </a:r>
+            <a:endParaRPr lang="en-US" sz="1200" dirty="0"/>
+          </a:p>
+        </p:txBody>
+      </p:sp>
+      <p:sp>
+        <p:nvSpPr>
+          <p:cNvPr id="34" name="Text 26"/>
+          <p:cNvSpPr txBox="1"/>
+          <p:nvPr/>
+        </p:nvSpPr>
+        <p:spPr>
+          <a:xfrm>
+            <a:off x="6756383" y="4457689"/>
+            <a:ext cx="4825988" cy="355599"/>
+          </a:xfrm>
+          <a:prstGeom prst="rect">
+            <a:avLst/>
+          </a:prstGeom>
+          <a:noFill/>
+          <a:ln/>
+        </p:spPr>
+        <p:txBody>
+          <a:bodyPr wrap="square" lIns="0" tIns="0" rIns="0" bIns="0" rtlCol="0" anchor="t"/>
+          <a:lstStyle/>
+          <a:p>
+            <a:pPr indent="0" marL="0">
+              <a:lnSpc>
+                <a:spcPct val="130000"/>
+              </a:lnSpc>
+              <a:buNone/>
+            </a:pPr>
+            <a:r>
+              <a:rPr lang="en-US" sz="950" dirty="0">
+                <a:solidFill>
+                  <a:srgbClr val="6F6A5C"/>
+                </a:solidFill>
+                <a:latin typeface="Arial" pitchFamily="34" charset="0"/>
+                <a:ea typeface="Arial" pitchFamily="34" charset="-122"/>
+                <a:cs typeface="Arial" pitchFamily="34" charset="-120"/>
+              </a:rPr>
+              <a:t>Vastgelegd in een verwerkersovereenkomst.</a:t>
+            </a:r>
+            <a:endParaRPr lang="en-US" sz="950" dirty="0"/>
+          </a:p>
+        </p:txBody>
+      </p:sp>
+      <p:sp>
+        <p:nvSpPr>
+          <p:cNvPr id="35" name="Shape 27"/>
+          <p:cNvSpPr/>
+          <p:nvPr/>
+        </p:nvSpPr>
+        <p:spPr>
+          <a:xfrm>
+            <a:off x="609598" y="4851388"/>
+            <a:ext cx="5232387" cy="0"/>
+          </a:xfrm>
+          <a:prstGeom prst="line">
+            <a:avLst/>
+          </a:prstGeom>
+          <a:noFill/>
+          <a:ln w="6350">
+            <a:solidFill>
+              <a:srgbClr val="C9C2B2"/>
+            </a:solidFill>
+            <a:prstDash val="solid"/>
+          </a:ln>
+        </p:spPr>
+      </p:sp>
+      <p:sp>
+        <p:nvSpPr>
+          <p:cNvPr id="36" name="Shape 28"/>
+          <p:cNvSpPr/>
+          <p:nvPr/>
+        </p:nvSpPr>
+        <p:spPr>
+          <a:xfrm>
+            <a:off x="609598" y="4952988"/>
+            <a:ext cx="253999" cy="253999"/>
+          </a:xfrm>
+          <a:prstGeom prst="roundRect">
+            <a:avLst>
+              <a:gd name="adj" fmla="val 25000"/>
+            </a:avLst>
+          </a:prstGeom>
+          <a:solidFill>
+            <a:srgbClr val="DDEBF3"/>
+          </a:solidFill>
+          <a:ln/>
+        </p:spPr>
+      </p:sp>
+      <p:pic>
+        <p:nvPicPr>
+          <p:cNvPr id="37" name="Image 6" descr="preencoded.png">    </p:cNvPr>
+          <p:cNvPicPr>
+            <a:picLocks noChangeAspect="1"/>
+          </p:cNvPicPr>
+          <p:nvPr/>
+        </p:nvPicPr>
+        <p:blipFill>
+          <a:blip r:embed="rId7"/>
+          <a:stretch>
+            <a:fillRect/>
+          </a:stretch>
+        </p:blipFill>
+        <p:spPr>
+          <a:xfrm>
+            <a:off x="666748" y="5010137"/>
+            <a:ext cx="139700" cy="139700"/>
+          </a:xfrm>
+          <a:prstGeom prst="rect">
+            <a:avLst/>
+          </a:prstGeom>
+        </p:spPr>
+      </p:pic>
+      <p:sp>
+        <p:nvSpPr>
+          <p:cNvPr id="38" name="Text 29"/>
+          <p:cNvSpPr txBox="1"/>
+          <p:nvPr/>
+        </p:nvSpPr>
+        <p:spPr>
+          <a:xfrm>
+            <a:off x="1015997" y="4927588"/>
+            <a:ext cx="4825988" cy="228599"/>
+          </a:xfrm>
+          <a:prstGeom prst="rect">
+            <a:avLst/>
+          </a:prstGeom>
+          <a:noFill/>
+          <a:ln/>
+        </p:spPr>
+        <p:txBody>
+          <a:bodyPr wrap="square" lIns="0" tIns="0" rIns="0" bIns="0" rtlCol="0" anchor="ctr"/>
+          <a:lstStyle/>
+          <a:p>
+            <a:pPr indent="0" marL="0">
+              <a:buNone/>
+            </a:pPr>
+            <a:r>
+              <a:rPr lang="en-US" sz="1200" b="1" dirty="0">
+                <a:solidFill>
+                  <a:srgbClr val="1C2230"/>
+                </a:solidFill>
+                <a:latin typeface="Arial" pitchFamily="34" charset="0"/>
+                <a:ea typeface="Arial" pitchFamily="34" charset="-122"/>
+                <a:cs typeface="Arial" pitchFamily="34" charset="-120"/>
+              </a:rPr>
+              <a:t>Evaluatie om de week</a:t>
+            </a:r>
+            <a:endParaRPr lang="en-US" sz="1200" dirty="0"/>
+          </a:p>
+        </p:txBody>
+      </p:sp>
+      <p:sp>
+        <p:nvSpPr>
+          <p:cNvPr id="39" name="Text 30"/>
+          <p:cNvSpPr txBox="1"/>
+          <p:nvPr/>
+        </p:nvSpPr>
+        <p:spPr>
+          <a:xfrm>
+            <a:off x="1015997" y="5168887"/>
+            <a:ext cx="4825988" cy="355599"/>
+          </a:xfrm>
+          <a:prstGeom prst="rect">
+            <a:avLst/>
+          </a:prstGeom>
+          <a:noFill/>
+          <a:ln/>
+        </p:spPr>
+        <p:txBody>
+          <a:bodyPr wrap="square" lIns="0" tIns="0" rIns="0" bIns="0" rtlCol="0" anchor="t"/>
+          <a:lstStyle/>
+          <a:p>
+            <a:pPr indent="0" marL="0">
+              <a:lnSpc>
+                <a:spcPct val="130000"/>
+              </a:lnSpc>
+              <a:buNone/>
+            </a:pPr>
+            <a:r>
+              <a:rPr lang="en-US" sz="950" dirty="0">
+                <a:solidFill>
+                  <a:srgbClr val="6F6A5C"/>
+                </a:solidFill>
+                <a:latin typeface="Arial" pitchFamily="34" charset="0"/>
+                <a:ea typeface="Arial" pitchFamily="34" charset="-122"/>
+                <a:cs typeface="Arial" pitchFamily="34" charset="-120"/>
+              </a:rPr>
+              <a:t>Bij twijfel om tafel en bijsturen.</a:t>
+            </a:r>
+            <a:endParaRPr lang="en-US" sz="950" dirty="0"/>
+          </a:p>
+        </p:txBody>
+      </p:sp>
+      <p:sp>
+        <p:nvSpPr>
+          <p:cNvPr id="40" name="Shape 31"/>
+          <p:cNvSpPr/>
+          <p:nvPr/>
+        </p:nvSpPr>
+        <p:spPr>
+          <a:xfrm>
+            <a:off x="6349984" y="4851388"/>
+            <a:ext cx="5232387" cy="0"/>
+          </a:xfrm>
+          <a:prstGeom prst="line">
+            <a:avLst/>
+          </a:prstGeom>
+          <a:noFill/>
+          <a:ln w="6350">
+            <a:solidFill>
+              <a:srgbClr val="C9C2B2"/>
+            </a:solidFill>
+            <a:prstDash val="solid"/>
+          </a:ln>
+        </p:spPr>
+      </p:sp>
+      <p:sp>
+        <p:nvSpPr>
+          <p:cNvPr id="41" name="Shape 32"/>
+          <p:cNvSpPr/>
+          <p:nvPr/>
+        </p:nvSpPr>
+        <p:spPr>
+          <a:xfrm>
+            <a:off x="6349984" y="4952988"/>
+            <a:ext cx="253999" cy="253999"/>
+          </a:xfrm>
+          <a:prstGeom prst="roundRect">
+            <a:avLst>
+              <a:gd name="adj" fmla="val 25000"/>
+            </a:avLst>
+          </a:prstGeom>
+          <a:solidFill>
+            <a:srgbClr val="DDEBF3"/>
+          </a:solidFill>
+          <a:ln/>
+        </p:spPr>
+      </p:sp>
+      <p:pic>
+        <p:nvPicPr>
+          <p:cNvPr id="42" name="Image 7" descr="preencoded.png">    </p:cNvPr>
+          <p:cNvPicPr>
+            <a:picLocks noChangeAspect="1"/>
+          </p:cNvPicPr>
+          <p:nvPr/>
+        </p:nvPicPr>
+        <p:blipFill>
+          <a:blip r:embed="rId8"/>
+          <a:stretch>
+            <a:fillRect/>
+          </a:stretch>
+        </p:blipFill>
+        <p:spPr>
+          <a:xfrm>
+            <a:off x="6407134" y="5010137"/>
+            <a:ext cx="139700" cy="139700"/>
+          </a:xfrm>
+          <a:prstGeom prst="rect">
+            <a:avLst/>
+          </a:prstGeom>
+        </p:spPr>
+      </p:pic>
+      <p:sp>
+        <p:nvSpPr>
+          <p:cNvPr id="43" name="Text 33"/>
+          <p:cNvSpPr txBox="1"/>
+          <p:nvPr/>
+        </p:nvSpPr>
+        <p:spPr>
+          <a:xfrm>
+            <a:off x="6756383" y="4927588"/>
+            <a:ext cx="4825988" cy="228599"/>
+          </a:xfrm>
+          <a:prstGeom prst="rect">
+            <a:avLst/>
+          </a:prstGeom>
+          <a:noFill/>
+          <a:ln/>
+        </p:spPr>
+        <p:txBody>
+          <a:bodyPr wrap="square" lIns="0" tIns="0" rIns="0" bIns="0" rtlCol="0" anchor="ctr"/>
+          <a:lstStyle/>
+          <a:p>
+            <a:pPr indent="0" marL="0">
+              <a:buNone/>
+            </a:pPr>
+            <a:r>
+              <a:rPr lang="en-US" sz="1200" b="1" dirty="0">
+                <a:solidFill>
+                  <a:srgbClr val="1C2230"/>
+                </a:solidFill>
+                <a:latin typeface="Arial" pitchFamily="34" charset="0"/>
+                <a:ea typeface="Arial" pitchFamily="34" charset="-122"/>
+                <a:cs typeface="Arial" pitchFamily="34" charset="-120"/>
+              </a:rPr>
+              <a:t>Alles op papier</a:t>
+            </a:r>
+            <a:endParaRPr lang="en-US" sz="1200" dirty="0"/>
+          </a:p>
+        </p:txBody>
+      </p:sp>
+      <p:sp>
+        <p:nvSpPr>
+          <p:cNvPr id="44" name="Text 34"/>
+          <p:cNvSpPr txBox="1"/>
+          <p:nvPr/>
+        </p:nvSpPr>
+        <p:spPr>
+          <a:xfrm>
+            <a:off x="6756383" y="5168887"/>
+            <a:ext cx="4825988" cy="355599"/>
+          </a:xfrm>
+          <a:prstGeom prst="rect">
+            <a:avLst/>
+          </a:prstGeom>
+          <a:noFill/>
+          <a:ln/>
+        </p:spPr>
+        <p:txBody>
+          <a:bodyPr wrap="square" lIns="0" tIns="0" rIns="0" bIns="0" rtlCol="0" anchor="t"/>
+          <a:lstStyle/>
+          <a:p>
+            <a:pPr indent="0" marL="0">
+              <a:lnSpc>
+                <a:spcPct val="130000"/>
+              </a:lnSpc>
+              <a:buNone/>
+            </a:pPr>
+            <a:r>
+              <a:rPr lang="en-US" sz="950" dirty="0">
+                <a:solidFill>
+                  <a:srgbClr val="6F6A5C"/>
+                </a:solidFill>
+                <a:latin typeface="Arial" pitchFamily="34" charset="0"/>
+                <a:ea typeface="Arial" pitchFamily="34" charset="-122"/>
+                <a:cs typeface="Arial" pitchFamily="34" charset="-120"/>
+              </a:rPr>
+              <a:t>Vastgelegd in een korte samenwerkingsovereenkomst.</a:t>
+            </a:r>
+            <a:endParaRPr lang="en-US" sz="950" dirty="0"/>
+          </a:p>
+        </p:txBody>
+      </p:sp>
+    </p:spTree>
+  </p:cSld>
+  <p:clrMapOvr>
+    <a:masterClrMapping/>
+  </p:clrMapOvr>
+</p:sld>
+</file>
+
+<file path=ppt/slides/slide11.xml><?xml version="1.0" encoding="utf-8"?>
+<p:sld xmlns:a="http://schemas.openxmlformats.org/drawingml/2006/main" xmlns:r="http://schemas.openxmlformats.org/officeDocument/2006/relationships" xmlns:p="http://schemas.openxmlformats.org/presentationml/2006/main">
+  <p:cSld name="Slide 11">
     <p:bg>
       <p:bgPr>
         <a:solidFill>
@@ -2859,7 +4380,7 @@
                 <a:ea typeface="Arial" pitchFamily="34" charset="-122"/>
                 <a:cs typeface="Arial" pitchFamily="34" charset="-120"/>
               </a:rPr>
-              <a:t>10 / 10</a:t>
+              <a:t>11 / 11</a:t>
             </a:r>
             <a:endParaRPr lang="en-US" sz="750" dirty="0"/>
           </a:p>
@@ -3785,7 +5306,7 @@
                 <a:ea typeface="Arial" pitchFamily="34" charset="-122"/>
                 <a:cs typeface="Arial" pitchFamily="34" charset="-120"/>
               </a:rPr>
-              <a:t>2 / 10</a:t>
+              <a:t>2 / 11</a:t>
             </a:r>
             <a:endParaRPr lang="en-US" sz="750" dirty="0"/>
           </a:p>
@@ -4412,7 +5933,7 @@
                 <a:ea typeface="Arial" pitchFamily="34" charset="-122"/>
                 <a:cs typeface="Arial" pitchFamily="34" charset="-120"/>
               </a:rPr>
-              <a:t>3 / 10</a:t>
+              <a:t>3 / 11</a:t>
             </a:r>
             <a:endParaRPr lang="en-US" sz="750" dirty="0"/>
           </a:p>
@@ -5298,7 +6819,7 @@
                 <a:ea typeface="Arial" pitchFamily="34" charset="-122"/>
                 <a:cs typeface="Arial" pitchFamily="34" charset="-120"/>
               </a:rPr>
-              <a:t>4 / 10</a:t>
+              <a:t>4 / 11</a:t>
             </a:r>
             <a:endParaRPr lang="en-US" sz="750" dirty="0"/>
           </a:p>
@@ -6537,7 +8058,7 @@
                 <a:ea typeface="Arial" pitchFamily="34" charset="-122"/>
                 <a:cs typeface="Arial" pitchFamily="34" charset="-120"/>
               </a:rPr>
-              <a:t>5 / 10</a:t>
+              <a:t>5 / 11</a:t>
             </a:r>
             <a:endParaRPr lang="en-US" sz="750" dirty="0"/>
           </a:p>
@@ -7321,7 +8842,7 @@
                 <a:ea typeface="Arial" pitchFamily="34" charset="-122"/>
                 <a:cs typeface="Arial" pitchFamily="34" charset="-120"/>
               </a:rPr>
-              <a:t>6 / 10</a:t>
+              <a:t>6 / 11</a:t>
             </a:r>
             <a:endParaRPr lang="en-US" sz="750" dirty="0"/>
           </a:p>
@@ -8829,7 +10350,7 @@
                 <a:ea typeface="Arial" pitchFamily="34" charset="-122"/>
                 <a:cs typeface="Arial" pitchFamily="34" charset="-120"/>
               </a:rPr>
-              <a:t>7 / 10</a:t>
+              <a:t>7 / 11</a:t>
             </a:r>
             <a:endParaRPr lang="en-US" sz="750" dirty="0"/>
           </a:p>
@@ -9499,7 +11020,7 @@
     <p:bg>
       <p:bgPr>
         <a:solidFill>
-          <a:srgbClr val="E9E0CD"/>
+          <a:srgbClr val="141821"/>
         </a:solidFill>
       </p:bgPr>
     </p:bg>
@@ -9544,7 +11065,7 @@
             <a:r>
               <a:rPr lang="en-US" sz="1800" b="1" dirty="0">
                 <a:solidFill>
-                  <a:srgbClr val="1C2230"/>
+                  <a:srgbClr val="F2EFE6"/>
                 </a:solidFill>
                 <a:latin typeface="Arial" pitchFamily="34" charset="0"/>
                 <a:ea typeface="Arial" pitchFamily="34" charset="-122"/>
@@ -9597,7 +11118,7 @@
             <a:r>
               <a:rPr lang="en-US" sz="750" b="1" spc="100" kern="0" dirty="0">
                 <a:solidFill>
-                  <a:srgbClr val="6F6A5C"/>
+                  <a:srgbClr val="BDC3CE"/>
                 </a:solidFill>
                 <a:latin typeface="Arial" pitchFamily="34" charset="0"/>
                 <a:ea typeface="Arial" pitchFamily="34" charset="-122"/>
@@ -9636,13 +11157,13 @@
             <a:r>
               <a:rPr lang="en-US" sz="750" b="1" spc="100" kern="0" dirty="0">
                 <a:solidFill>
-                  <a:srgbClr val="6F6A5C"/>
-                </a:solidFill>
-                <a:latin typeface="Arial" pitchFamily="34" charset="0"/>
-                <a:ea typeface="Arial" pitchFamily="34" charset="-122"/>
-                <a:cs typeface="Arial" pitchFamily="34" charset="-120"/>
-              </a:rPr>
-              <a:t>8 / 10</a:t>
+                  <a:srgbClr val="BDC3CE"/>
+                </a:solidFill>
+                <a:latin typeface="Arial" pitchFamily="34" charset="0"/>
+                <a:ea typeface="Arial" pitchFamily="34" charset="-122"/>
+                <a:cs typeface="Arial" pitchFamily="34" charset="-120"/>
+              </a:rPr>
+              <a:t>8 / 11</a:t>
             </a:r>
             <a:endParaRPr lang="en-US" sz="750" dirty="0"/>
           </a:p>
@@ -9681,7 +11202,7 @@
                 <a:ea typeface="Arial" pitchFamily="34" charset="-122"/>
                 <a:cs typeface="Arial" pitchFamily="34" charset="-120"/>
               </a:rPr>
-              <a:t>WAT WE VAN JULLIE NODIG HEBBEN</a:t>
+              <a:t>HOE WE VERDER GAAN</a:t>
             </a:r>
             <a:endParaRPr lang="en-US" sz="950" dirty="0"/>
           </a:p>
@@ -9717,13 +11238,13 @@
             <a:r>
               <a:rPr lang="en-US" sz="3200" b="1" dirty="0">
                 <a:solidFill>
-                  <a:srgbClr val="1C2230"/>
-                </a:solidFill>
-                <a:latin typeface="Arial" pitchFamily="34" charset="0"/>
-                <a:ea typeface="Arial" pitchFamily="34" charset="-122"/>
-                <a:cs typeface="Arial" pitchFamily="34" charset="-120"/>
-              </a:rPr>
-              <a:t>Een halve dag van jullie, dan </a:t>
+                  <a:srgbClr val="F2EFE6"/>
+                </a:solidFill>
+                <a:latin typeface="Arial" pitchFamily="34" charset="0"/>
+                <a:ea typeface="Arial" pitchFamily="34" charset="-122"/>
+                <a:cs typeface="Arial" pitchFamily="34" charset="-120"/>
+              </a:rPr>
+              <a:t>Jullie kopen geen uren, maar </a:t>
             </a:r>
             <a:pPr algn="l" indent="0" marL="0">
               <a:lnSpc>
@@ -9734,13 +11255,13 @@
             <a:r>
               <a:rPr lang="en-US" sz="3000" i="1" dirty="0">
                 <a:solidFill>
-                  <a:srgbClr val="1C2230"/>
+                  <a:srgbClr val="F2EFE6"/>
                 </a:solidFill>
                 <a:latin typeface="Georgia" pitchFamily="34" charset="0"/>
                 <a:ea typeface="Georgia" pitchFamily="34" charset="-122"/>
                 <a:cs typeface="Georgia" pitchFamily="34" charset="-120"/>
               </a:rPr>
-              <a:t>draaien wij</a:t>
+              <a:t>afspraken</a:t>
             </a:r>
             <a:pPr algn="l" indent="0" marL="0">
               <a:lnSpc>
@@ -9751,7 +11272,7 @@
             <a:r>
               <a:rPr lang="en-US" sz="3200" b="1" dirty="0">
                 <a:solidFill>
-                  <a:srgbClr val="1C2230"/>
+                  <a:srgbClr val="F2EFE6"/>
                 </a:solidFill>
                 <a:latin typeface="Arial" pitchFamily="34" charset="0"/>
                 <a:ea typeface="Arial" pitchFamily="34" charset="-122"/>
@@ -9772,17 +11293,22 @@
         <p:spPr>
           <a:xfrm>
             <a:off x="609598" y="2793993"/>
-            <a:ext cx="5397487" cy="1530346"/>
+            <a:ext cx="2628893" cy="2285994"/>
           </a:xfrm>
           <a:prstGeom prst="roundRect">
             <a:avLst>
-              <a:gd name="adj" fmla="val 6639"/>
+              <a:gd name="adj" fmla="val 4444"/>
             </a:avLst>
           </a:prstGeom>
           <a:solidFill>
-            <a:srgbClr val="F8F4EB"/>
+            <a:srgbClr val="1B2130"/>
           </a:solidFill>
-          <a:ln/>
+          <a:ln w="9525">
+            <a:solidFill>
+              <a:srgbClr val="3A4152"/>
+            </a:solidFill>
+            <a:prstDash val="solid"/>
+          </a:ln>
         </p:spPr>
       </p:sp>
       <p:sp>
@@ -9793,54 +11319,202 @@
         </p:nvSpPr>
         <p:spPr>
           <a:xfrm>
-            <a:off x="939798" y="3098792"/>
-            <a:ext cx="380999" cy="380999"/>
+            <a:off x="825498" y="3022592"/>
+            <a:ext cx="292099" cy="292099"/>
+          </a:xfrm>
+          <a:prstGeom prst="ellipse">
+            <a:avLst/>
+          </a:prstGeom>
+          <a:ln w="15240">
+            <a:solidFill>
+              <a:srgbClr val="38B6FF"/>
+            </a:solidFill>
+            <a:prstDash val="solid"/>
+          </a:ln>
+        </p:spPr>
+      </p:sp>
+      <p:sp>
+        <p:nvSpPr>
+          <p:cNvPr id="9" name="Text 7"/>
+          <p:cNvSpPr txBox="1"/>
+          <p:nvPr/>
+        </p:nvSpPr>
+        <p:spPr>
+          <a:xfrm>
+            <a:off x="825498" y="3022592"/>
+            <a:ext cx="292099" cy="292099"/>
+          </a:xfrm>
+          <a:prstGeom prst="rect">
+            <a:avLst/>
+          </a:prstGeom>
+          <a:noFill/>
+          <a:ln/>
+        </p:spPr>
+        <p:txBody>
+          <a:bodyPr wrap="square" lIns="0" tIns="0" rIns="0" bIns="0" rtlCol="0" anchor="ctr"/>
+          <a:lstStyle/>
+          <a:p>
+            <a:pPr algn="ctr" indent="0" marL="0">
+              <a:buNone/>
+            </a:pPr>
+            <a:r>
+              <a:rPr lang="en-US" sz="1000" b="1" dirty="0">
+                <a:solidFill>
+                  <a:srgbClr val="38B6FF"/>
+                </a:solidFill>
+                <a:latin typeface="Arial" pitchFamily="34" charset="0"/>
+                <a:ea typeface="Arial" pitchFamily="34" charset="-122"/>
+                <a:cs typeface="Arial" pitchFamily="34" charset="-120"/>
+              </a:rPr>
+              <a:t>1</a:t>
+            </a:r>
+            <a:endParaRPr lang="en-US" sz="1000" dirty="0"/>
+          </a:p>
+        </p:txBody>
+      </p:sp>
+      <p:sp>
+        <p:nvSpPr>
+          <p:cNvPr id="10" name="Text 8"/>
+          <p:cNvSpPr txBox="1"/>
+          <p:nvPr/>
+        </p:nvSpPr>
+        <p:spPr>
+          <a:xfrm>
+            <a:off x="825498" y="3467091"/>
+            <a:ext cx="2197095" cy="406399"/>
+          </a:xfrm>
+          <a:prstGeom prst="rect">
+            <a:avLst/>
+          </a:prstGeom>
+          <a:noFill/>
+          <a:ln/>
+        </p:spPr>
+        <p:txBody>
+          <a:bodyPr wrap="square" lIns="0" tIns="0" rIns="0" bIns="0" rtlCol="0" anchor="t"/>
+          <a:lstStyle/>
+          <a:p>
+            <a:pPr indent="0" marL="0">
+              <a:lnSpc>
+                <a:spcPct val="115000"/>
+              </a:lnSpc>
+              <a:buNone/>
+            </a:pPr>
+            <a:r>
+              <a:rPr lang="en-US" sz="1150" b="1" dirty="0">
+                <a:solidFill>
+                  <a:srgbClr val="F2EFE6"/>
+                </a:solidFill>
+                <a:latin typeface="Arial" pitchFamily="34" charset="0"/>
+                <a:ea typeface="Arial" pitchFamily="34" charset="-122"/>
+                <a:cs typeface="Arial" pitchFamily="34" charset="-120"/>
+              </a:rPr>
+              <a:t>Vaste bezetting</a:t>
+            </a:r>
+            <a:endParaRPr lang="en-US" sz="1150" dirty="0"/>
+          </a:p>
+        </p:txBody>
+      </p:sp>
+      <p:sp>
+        <p:nvSpPr>
+          <p:cNvPr id="11" name="Text 9"/>
+          <p:cNvSpPr txBox="1"/>
+          <p:nvPr/>
+        </p:nvSpPr>
+        <p:spPr>
+          <a:xfrm>
+            <a:off x="825498" y="3924290"/>
+            <a:ext cx="2197095" cy="1079497"/>
+          </a:xfrm>
+          <a:prstGeom prst="rect">
+            <a:avLst/>
+          </a:prstGeom>
+          <a:noFill/>
+          <a:ln/>
+        </p:spPr>
+        <p:txBody>
+          <a:bodyPr wrap="square" lIns="0" tIns="0" rIns="0" bIns="0" rtlCol="0" anchor="t"/>
+          <a:lstStyle/>
+          <a:p>
+            <a:pPr indent="0" marL="0">
+              <a:lnSpc>
+                <a:spcPct val="130000"/>
+              </a:lnSpc>
+              <a:buNone/>
+            </a:pPr>
+            <a:r>
+              <a:rPr lang="en-US" sz="875" dirty="0">
+                <a:solidFill>
+                  <a:srgbClr val="C2C8D2"/>
+                </a:solidFill>
+                <a:latin typeface="Arial" pitchFamily="34" charset="0"/>
+                <a:ea typeface="Arial" pitchFamily="34" charset="-122"/>
+                <a:cs typeface="Arial" pitchFamily="34" charset="-120"/>
+              </a:rPr>
+              <a:t>Jullie kiezen hoeveel dagdelen per week we voor jullie bellen. Hoe meer bezetting, hoe scherper het tarief, want dan draait een vaste beller vol op jullie verhaal.</a:t>
+            </a:r>
+            <a:endParaRPr lang="en-US" sz="875" dirty="0"/>
+          </a:p>
+        </p:txBody>
+      </p:sp>
+      <p:sp>
+        <p:nvSpPr>
+          <p:cNvPr id="12" name="Shape 10"/>
+          <p:cNvSpPr/>
+          <p:nvPr/>
+        </p:nvSpPr>
+        <p:spPr>
+          <a:xfrm>
+            <a:off x="3390892" y="2793993"/>
+            <a:ext cx="2628893" cy="2285994"/>
           </a:xfrm>
           <a:prstGeom prst="roundRect">
             <a:avLst>
-              <a:gd name="adj" fmla="val 23333"/>
+              <a:gd name="adj" fmla="val 4444"/>
             </a:avLst>
           </a:prstGeom>
           <a:solidFill>
-            <a:srgbClr val="DDEBF3"/>
+            <a:srgbClr val="1B2130"/>
           </a:solidFill>
-          <a:ln/>
-        </p:spPr>
-      </p:sp>
-      <p:pic>
-        <p:nvPicPr>
-          <p:cNvPr id="9" name="Image 0" descr="preencoded.png">    </p:cNvPr>
-          <p:cNvPicPr>
-            <a:picLocks noChangeAspect="1"/>
-          </p:cNvPicPr>
-          <p:nvPr/>
-        </p:nvPicPr>
-        <p:blipFill>
-          <a:blip r:embed="rId1"/>
-          <a:stretch>
-            <a:fillRect/>
-          </a:stretch>
-        </p:blipFill>
-        <p:spPr>
-          <a:xfrm>
-            <a:off x="1035047" y="3194042"/>
-            <a:ext cx="190500" cy="190500"/>
-          </a:xfrm>
-          <a:prstGeom prst="rect">
-            <a:avLst/>
-          </a:prstGeom>
-        </p:spPr>
-      </p:pic>
-      <p:sp>
-        <p:nvSpPr>
-          <p:cNvPr id="10" name="Text 7"/>
-          <p:cNvSpPr txBox="1"/>
-          <p:nvPr/>
-        </p:nvSpPr>
-        <p:spPr>
-          <a:xfrm>
-            <a:off x="1549396" y="3073392"/>
-            <a:ext cx="4127490" cy="279399"/>
+          <a:ln w="9525">
+            <a:solidFill>
+              <a:srgbClr val="3A4152"/>
+            </a:solidFill>
+            <a:prstDash val="solid"/>
+          </a:ln>
+        </p:spPr>
+      </p:sp>
+      <p:sp>
+        <p:nvSpPr>
+          <p:cNvPr id="13" name="Shape 11"/>
+          <p:cNvSpPr/>
+          <p:nvPr/>
+        </p:nvSpPr>
+        <p:spPr>
+          <a:xfrm>
+            <a:off x="3606791" y="3022592"/>
+            <a:ext cx="292099" cy="292099"/>
+          </a:xfrm>
+          <a:prstGeom prst="ellipse">
+            <a:avLst/>
+          </a:prstGeom>
+          <a:ln w="15240">
+            <a:solidFill>
+              <a:srgbClr val="38B6FF"/>
+            </a:solidFill>
+            <a:prstDash val="solid"/>
+          </a:ln>
+        </p:spPr>
+      </p:sp>
+      <p:sp>
+        <p:nvSpPr>
+          <p:cNvPr id="14" name="Text 12"/>
+          <p:cNvSpPr txBox="1"/>
+          <p:nvPr/>
+        </p:nvSpPr>
+        <p:spPr>
+          <a:xfrm>
+            <a:off x="3606791" y="3022592"/>
+            <a:ext cx="292099" cy="292099"/>
           </a:xfrm>
           <a:prstGeom prst="rect">
             <a:avLst/>
@@ -9852,34 +11526,34 @@
           <a:bodyPr wrap="square" lIns="0" tIns="0" rIns="0" bIns="0" rtlCol="0" anchor="ctr"/>
           <a:lstStyle/>
           <a:p>
-            <a:pPr indent="0" marL="0">
-              <a:buNone/>
-            </a:pPr>
-            <a:r>
-              <a:rPr lang="en-US" sz="1450" b="1" dirty="0">
-                <a:solidFill>
-                  <a:srgbClr val="1C2230"/>
-                </a:solidFill>
-                <a:latin typeface="Arial" pitchFamily="34" charset="0"/>
-                <a:ea typeface="Arial" pitchFamily="34" charset="-122"/>
-                <a:cs typeface="Arial" pitchFamily="34" charset="-120"/>
-              </a:rPr>
-              <a:t>Kick-off sessie</a:t>
-            </a:r>
-            <a:endParaRPr lang="en-US" sz="1450" dirty="0"/>
-          </a:p>
-        </p:txBody>
-      </p:sp>
-      <p:sp>
-        <p:nvSpPr>
-          <p:cNvPr id="11" name="Text 8"/>
-          <p:cNvSpPr txBox="1"/>
-          <p:nvPr/>
-        </p:nvSpPr>
-        <p:spPr>
-          <a:xfrm>
-            <a:off x="1549396" y="3403591"/>
-            <a:ext cx="4063990" cy="698498"/>
+            <a:pPr algn="ctr" indent="0" marL="0">
+              <a:buNone/>
+            </a:pPr>
+            <a:r>
+              <a:rPr lang="en-US" sz="1000" b="1" dirty="0">
+                <a:solidFill>
+                  <a:srgbClr val="38B6FF"/>
+                </a:solidFill>
+                <a:latin typeface="Arial" pitchFamily="34" charset="0"/>
+                <a:ea typeface="Arial" pitchFamily="34" charset="-122"/>
+                <a:cs typeface="Arial" pitchFamily="34" charset="-120"/>
+              </a:rPr>
+              <a:t>2</a:t>
+            </a:r>
+            <a:endParaRPr lang="en-US" sz="1000" dirty="0"/>
+          </a:p>
+        </p:txBody>
+      </p:sp>
+      <p:sp>
+        <p:nvSpPr>
+          <p:cNvPr id="15" name="Text 13"/>
+          <p:cNvSpPr txBox="1"/>
+          <p:nvPr/>
+        </p:nvSpPr>
+        <p:spPr>
+          <a:xfrm>
+            <a:off x="3606791" y="3467091"/>
+            <a:ext cx="2197095" cy="406399"/>
           </a:xfrm>
           <a:prstGeom prst="rect">
             <a:avLst/>
@@ -9893,103 +11567,298 @@
           <a:p>
             <a:pPr indent="0" marL="0">
               <a:lnSpc>
-                <a:spcPct val="135000"/>
+                <a:spcPct val="115000"/>
               </a:lnSpc>
               <a:buNone/>
             </a:pPr>
             <a:r>
-              <a:rPr lang="en-US" sz="1050" dirty="0">
-                <a:solidFill>
-                  <a:srgbClr val="6F6A5C"/>
-                </a:solidFill>
-                <a:latin typeface="Arial" pitchFamily="34" charset="0"/>
-                <a:ea typeface="Arial" pitchFamily="34" charset="-122"/>
-                <a:cs typeface="Arial" pitchFamily="34" charset="-120"/>
-              </a:rPr>
-              <a:t>Anderhalf tot twee uur met Bernhard en degene die de afspraken gaat voeren.</a:t>
-            </a:r>
-            <a:endParaRPr lang="en-US" sz="1050" dirty="0"/>
-          </a:p>
-        </p:txBody>
-      </p:sp>
-      <p:sp>
-        <p:nvSpPr>
-          <p:cNvPr id="12" name="Shape 9"/>
+              <a:rPr lang="en-US" sz="1150" b="1" dirty="0">
+                <a:solidFill>
+                  <a:srgbClr val="F2EFE6"/>
+                </a:solidFill>
+                <a:latin typeface="Arial" pitchFamily="34" charset="0"/>
+                <a:ea typeface="Arial" pitchFamily="34" charset="-122"/>
+                <a:cs typeface="Arial" pitchFamily="34" charset="-120"/>
+              </a:rPr>
+              <a:t>Vast target</a:t>
+            </a:r>
+            <a:endParaRPr lang="en-US" sz="1150" dirty="0"/>
+          </a:p>
+        </p:txBody>
+      </p:sp>
+      <p:sp>
+        <p:nvSpPr>
+          <p:cNvPr id="16" name="Text 14"/>
+          <p:cNvSpPr txBox="1"/>
+          <p:nvPr/>
+        </p:nvSpPr>
+        <p:spPr>
+          <a:xfrm>
+            <a:off x="3606791" y="3924290"/>
+            <a:ext cx="2197095" cy="1079497"/>
+          </a:xfrm>
+          <a:prstGeom prst="rect">
+            <a:avLst/>
+          </a:prstGeom>
+          <a:noFill/>
+          <a:ln/>
+        </p:spPr>
+        <p:txBody>
+          <a:bodyPr wrap="square" lIns="0" tIns="0" rIns="0" bIns="0" rtlCol="0" anchor="t"/>
+          <a:lstStyle/>
+          <a:p>
+            <a:pPr indent="0" marL="0">
+              <a:lnSpc>
+                <a:spcPct val="130000"/>
+              </a:lnSpc>
+              <a:buNone/>
+            </a:pPr>
+            <a:r>
+              <a:rPr lang="en-US" sz="875" dirty="0">
+                <a:solidFill>
+                  <a:srgbClr val="C2C8D2"/>
+                </a:solidFill>
+                <a:latin typeface="Arial" pitchFamily="34" charset="0"/>
+                <a:ea typeface="Arial" pitchFamily="34" charset="-122"/>
+                <a:cs typeface="Arial" pitchFamily="34" charset="-120"/>
+              </a:rPr>
+              <a:t>Aan die bezetting hangt een vast aantal gekwalificeerde afspraken per werkperiode. Dat getal komt uit jullie eigen pilot, niet uit een aanname.</a:t>
+            </a:r>
+            <a:endParaRPr lang="en-US" sz="875" dirty="0"/>
+          </a:p>
+        </p:txBody>
+      </p:sp>
+      <p:sp>
+        <p:nvSpPr>
+          <p:cNvPr id="17" name="Shape 15"/>
           <p:cNvSpPr/>
           <p:nvPr/>
         </p:nvSpPr>
         <p:spPr>
           <a:xfrm>
-            <a:off x="6184885" y="2793993"/>
-            <a:ext cx="5397487" cy="1530346"/>
+            <a:off x="6172185" y="2793993"/>
+            <a:ext cx="2628893" cy="2285994"/>
           </a:xfrm>
           <a:prstGeom prst="roundRect">
             <a:avLst>
-              <a:gd name="adj" fmla="val 6639"/>
+              <a:gd name="adj" fmla="val 4444"/>
             </a:avLst>
           </a:prstGeom>
           <a:solidFill>
-            <a:srgbClr val="F8F4EB"/>
+            <a:srgbClr val="1B2130"/>
           </a:solidFill>
-          <a:ln/>
-        </p:spPr>
-      </p:sp>
-      <p:sp>
-        <p:nvSpPr>
-          <p:cNvPr id="13" name="Shape 10"/>
+          <a:ln w="9525">
+            <a:solidFill>
+              <a:srgbClr val="3A4152"/>
+            </a:solidFill>
+            <a:prstDash val="solid"/>
+          </a:ln>
+        </p:spPr>
+      </p:sp>
+      <p:sp>
+        <p:nvSpPr>
+          <p:cNvPr id="18" name="Shape 16"/>
           <p:cNvSpPr/>
           <p:nvPr/>
         </p:nvSpPr>
         <p:spPr>
           <a:xfrm>
-            <a:off x="6515084" y="3098792"/>
-            <a:ext cx="380999" cy="380999"/>
+            <a:off x="6388084" y="3022592"/>
+            <a:ext cx="292099" cy="292099"/>
+          </a:xfrm>
+          <a:prstGeom prst="ellipse">
+            <a:avLst/>
+          </a:prstGeom>
+          <a:ln w="15240">
+            <a:solidFill>
+              <a:srgbClr val="38B6FF"/>
+            </a:solidFill>
+            <a:prstDash val="solid"/>
+          </a:ln>
+        </p:spPr>
+      </p:sp>
+      <p:sp>
+        <p:nvSpPr>
+          <p:cNvPr id="19" name="Text 17"/>
+          <p:cNvSpPr txBox="1"/>
+          <p:nvPr/>
+        </p:nvSpPr>
+        <p:spPr>
+          <a:xfrm>
+            <a:off x="6388084" y="3022592"/>
+            <a:ext cx="292099" cy="292099"/>
+          </a:xfrm>
+          <a:prstGeom prst="rect">
+            <a:avLst/>
+          </a:prstGeom>
+          <a:noFill/>
+          <a:ln/>
+        </p:spPr>
+        <p:txBody>
+          <a:bodyPr wrap="square" lIns="0" tIns="0" rIns="0" bIns="0" rtlCol="0" anchor="ctr"/>
+          <a:lstStyle/>
+          <a:p>
+            <a:pPr algn="ctr" indent="0" marL="0">
+              <a:buNone/>
+            </a:pPr>
+            <a:r>
+              <a:rPr lang="en-US" sz="1000" b="1" dirty="0">
+                <a:solidFill>
+                  <a:srgbClr val="38B6FF"/>
+                </a:solidFill>
+                <a:latin typeface="Arial" pitchFamily="34" charset="0"/>
+                <a:ea typeface="Arial" pitchFamily="34" charset="-122"/>
+                <a:cs typeface="Arial" pitchFamily="34" charset="-120"/>
+              </a:rPr>
+              <a:t>3</a:t>
+            </a:r>
+            <a:endParaRPr lang="en-US" sz="1000" dirty="0"/>
+          </a:p>
+        </p:txBody>
+      </p:sp>
+      <p:sp>
+        <p:nvSpPr>
+          <p:cNvPr id="20" name="Text 18"/>
+          <p:cNvSpPr txBox="1"/>
+          <p:nvPr/>
+        </p:nvSpPr>
+        <p:spPr>
+          <a:xfrm>
+            <a:off x="6388084" y="3467091"/>
+            <a:ext cx="2197095" cy="406399"/>
+          </a:xfrm>
+          <a:prstGeom prst="rect">
+            <a:avLst/>
+          </a:prstGeom>
+          <a:noFill/>
+          <a:ln/>
+        </p:spPr>
+        <p:txBody>
+          <a:bodyPr wrap="square" lIns="0" tIns="0" rIns="0" bIns="0" rtlCol="0" anchor="t"/>
+          <a:lstStyle/>
+          <a:p>
+            <a:pPr indent="0" marL="0">
+              <a:lnSpc>
+                <a:spcPct val="115000"/>
+              </a:lnSpc>
+              <a:buNone/>
+            </a:pPr>
+            <a:r>
+              <a:rPr lang="en-US" sz="1150" b="1" dirty="0">
+                <a:solidFill>
+                  <a:srgbClr val="F2EFE6"/>
+                </a:solidFill>
+                <a:latin typeface="Arial" pitchFamily="34" charset="0"/>
+                <a:ea typeface="Arial" pitchFamily="34" charset="-122"/>
+                <a:cs typeface="Arial" pitchFamily="34" charset="-120"/>
+              </a:rPr>
+              <a:t>Onder target bellen we door</a:t>
+            </a:r>
+            <a:endParaRPr lang="en-US" sz="1150" dirty="0"/>
+          </a:p>
+        </p:txBody>
+      </p:sp>
+      <p:sp>
+        <p:nvSpPr>
+          <p:cNvPr id="21" name="Text 19"/>
+          <p:cNvSpPr txBox="1"/>
+          <p:nvPr/>
+        </p:nvSpPr>
+        <p:spPr>
+          <a:xfrm>
+            <a:off x="6388084" y="3924290"/>
+            <a:ext cx="2197095" cy="1079497"/>
+          </a:xfrm>
+          <a:prstGeom prst="rect">
+            <a:avLst/>
+          </a:prstGeom>
+          <a:noFill/>
+          <a:ln/>
+        </p:spPr>
+        <p:txBody>
+          <a:bodyPr wrap="square" lIns="0" tIns="0" rIns="0" bIns="0" rtlCol="0" anchor="t"/>
+          <a:lstStyle/>
+          <a:p>
+            <a:pPr indent="0" marL="0">
+              <a:lnSpc>
+                <a:spcPct val="130000"/>
+              </a:lnSpc>
+              <a:buNone/>
+            </a:pPr>
+            <a:r>
+              <a:rPr lang="en-US" sz="875" dirty="0">
+                <a:solidFill>
+                  <a:srgbClr val="C2C8D2"/>
+                </a:solidFill>
+                <a:latin typeface="Arial" pitchFamily="34" charset="0"/>
+                <a:ea typeface="Arial" pitchFamily="34" charset="-122"/>
+                <a:cs typeface="Arial" pitchFamily="34" charset="-120"/>
+              </a:rPr>
+              <a:t>Staat het aantal aan het eind van de werkperiode niet, dan bellen we door zonder extra kosten tot het er wel staat.</a:t>
+            </a:r>
+            <a:endParaRPr lang="en-US" sz="875" dirty="0"/>
+          </a:p>
+        </p:txBody>
+      </p:sp>
+      <p:sp>
+        <p:nvSpPr>
+          <p:cNvPr id="22" name="Shape 20"/>
+          <p:cNvSpPr/>
+          <p:nvPr/>
+        </p:nvSpPr>
+        <p:spPr>
+          <a:xfrm>
+            <a:off x="8953478" y="2793993"/>
+            <a:ext cx="2628893" cy="2285994"/>
           </a:xfrm>
           <a:prstGeom prst="roundRect">
             <a:avLst>
-              <a:gd name="adj" fmla="val 23333"/>
+              <a:gd name="adj" fmla="val 4444"/>
             </a:avLst>
           </a:prstGeom>
           <a:solidFill>
-            <a:srgbClr val="DDEBF3"/>
+            <a:srgbClr val="1B2130"/>
           </a:solidFill>
-          <a:ln/>
-        </p:spPr>
-      </p:sp>
-      <p:pic>
-        <p:nvPicPr>
-          <p:cNvPr id="14" name="Image 1" descr="preencoded.png">    </p:cNvPr>
-          <p:cNvPicPr>
-            <a:picLocks noChangeAspect="1"/>
-          </p:cNvPicPr>
-          <p:nvPr/>
-        </p:nvPicPr>
-        <p:blipFill>
-          <a:blip r:embed="rId2"/>
-          <a:stretch>
-            <a:fillRect/>
-          </a:stretch>
-        </p:blipFill>
-        <p:spPr>
-          <a:xfrm>
-            <a:off x="6610333" y="3194042"/>
-            <a:ext cx="190500" cy="190500"/>
-          </a:xfrm>
-          <a:prstGeom prst="rect">
-            <a:avLst/>
-          </a:prstGeom>
-        </p:spPr>
-      </p:pic>
-      <p:sp>
-        <p:nvSpPr>
-          <p:cNvPr id="15" name="Text 11"/>
-          <p:cNvSpPr txBox="1"/>
-          <p:nvPr/>
-        </p:nvSpPr>
-        <p:spPr>
-          <a:xfrm>
-            <a:off x="7124682" y="3073392"/>
-            <a:ext cx="4127490" cy="279399"/>
+          <a:ln w="15240">
+            <a:solidFill>
+              <a:srgbClr val="38B6FF"/>
+            </a:solidFill>
+            <a:prstDash val="solid"/>
+          </a:ln>
+        </p:spPr>
+      </p:sp>
+      <p:sp>
+        <p:nvSpPr>
+          <p:cNvPr id="23" name="Shape 21"/>
+          <p:cNvSpPr/>
+          <p:nvPr/>
+        </p:nvSpPr>
+        <p:spPr>
+          <a:xfrm>
+            <a:off x="9169377" y="3022592"/>
+            <a:ext cx="292099" cy="292099"/>
+          </a:xfrm>
+          <a:prstGeom prst="ellipse">
+            <a:avLst/>
+          </a:prstGeom>
+          <a:ln w="15240">
+            <a:solidFill>
+              <a:srgbClr val="38B6FF"/>
+            </a:solidFill>
+            <a:prstDash val="solid"/>
+          </a:ln>
+        </p:spPr>
+      </p:sp>
+      <p:sp>
+        <p:nvSpPr>
+          <p:cNvPr id="24" name="Text 22"/>
+          <p:cNvSpPr txBox="1"/>
+          <p:nvPr/>
+        </p:nvSpPr>
+        <p:spPr>
+          <a:xfrm>
+            <a:off x="9169377" y="3022592"/>
+            <a:ext cx="292099" cy="292099"/>
           </a:xfrm>
           <a:prstGeom prst="rect">
             <a:avLst/>
@@ -10001,34 +11870,34 @@
           <a:bodyPr wrap="square" lIns="0" tIns="0" rIns="0" bIns="0" rtlCol="0" anchor="ctr"/>
           <a:lstStyle/>
           <a:p>
-            <a:pPr indent="0" marL="0">
-              <a:buNone/>
-            </a:pPr>
-            <a:r>
-              <a:rPr lang="en-US" sz="1450" b="1" dirty="0">
-                <a:solidFill>
-                  <a:srgbClr val="1C2230"/>
-                </a:solidFill>
-                <a:latin typeface="Arial" pitchFamily="34" charset="0"/>
-                <a:ea typeface="Arial" pitchFamily="34" charset="-122"/>
-                <a:cs typeface="Arial" pitchFamily="34" charset="-120"/>
-              </a:rPr>
-              <a:t>Uitsluitlijst</a:t>
-            </a:r>
-            <a:endParaRPr lang="en-US" sz="1450" dirty="0"/>
-          </a:p>
-        </p:txBody>
-      </p:sp>
-      <p:sp>
-        <p:nvSpPr>
-          <p:cNvPr id="16" name="Text 12"/>
-          <p:cNvSpPr txBox="1"/>
-          <p:nvPr/>
-        </p:nvSpPr>
-        <p:spPr>
-          <a:xfrm>
-            <a:off x="7124682" y="3403591"/>
-            <a:ext cx="4063990" cy="698498"/>
+            <a:pPr algn="ctr" indent="0" marL="0">
+              <a:buNone/>
+            </a:pPr>
+            <a:r>
+              <a:rPr lang="en-US" sz="1000" b="1" dirty="0">
+                <a:solidFill>
+                  <a:srgbClr val="38B6FF"/>
+                </a:solidFill>
+                <a:latin typeface="Arial" pitchFamily="34" charset="0"/>
+                <a:ea typeface="Arial" pitchFamily="34" charset="-122"/>
+                <a:cs typeface="Arial" pitchFamily="34" charset="-120"/>
+              </a:rPr>
+              <a:t>4</a:t>
+            </a:r>
+            <a:endParaRPr lang="en-US" sz="1000" dirty="0"/>
+          </a:p>
+        </p:txBody>
+      </p:sp>
+      <p:sp>
+        <p:nvSpPr>
+          <p:cNvPr id="25" name="Text 23"/>
+          <p:cNvSpPr txBox="1"/>
+          <p:nvPr/>
+        </p:nvSpPr>
+        <p:spPr>
+          <a:xfrm>
+            <a:off x="9169377" y="3467091"/>
+            <a:ext cx="2197095" cy="406399"/>
           </a:xfrm>
           <a:prstGeom prst="rect">
             <a:avLst/>
@@ -10042,142 +11911,35 @@
           <a:p>
             <a:pPr indent="0" marL="0">
               <a:lnSpc>
-                <a:spcPct val="135000"/>
+                <a:spcPct val="115000"/>
               </a:lnSpc>
               <a:buNone/>
             </a:pPr>
             <a:r>
-              <a:rPr lang="en-US" sz="1050" dirty="0">
-                <a:solidFill>
-                  <a:srgbClr val="6F6A5C"/>
-                </a:solidFill>
-                <a:latin typeface="Arial" pitchFamily="34" charset="0"/>
-                <a:ea typeface="Arial" pitchFamily="34" charset="-122"/>
-                <a:cs typeface="Arial" pitchFamily="34" charset="-120"/>
-              </a:rPr>
-              <a:t>Bestaande klanten, lopende gesprekken en bedrijven die we niet mogen benaderen.</a:t>
-            </a:r>
-            <a:endParaRPr lang="en-US" sz="1050" dirty="0"/>
-          </a:p>
-        </p:txBody>
-      </p:sp>
-      <p:sp>
-        <p:nvSpPr>
-          <p:cNvPr id="17" name="Shape 13"/>
-          <p:cNvSpPr/>
-          <p:nvPr/>
-        </p:nvSpPr>
-        <p:spPr>
-          <a:xfrm>
-            <a:off x="609598" y="4502139"/>
-            <a:ext cx="5397487" cy="1530346"/>
-          </a:xfrm>
-          <a:prstGeom prst="roundRect">
-            <a:avLst>
-              <a:gd name="adj" fmla="val 6639"/>
-            </a:avLst>
-          </a:prstGeom>
-          <a:solidFill>
-            <a:srgbClr val="F8F4EB"/>
-          </a:solidFill>
-          <a:ln/>
-        </p:spPr>
-      </p:sp>
-      <p:sp>
-        <p:nvSpPr>
-          <p:cNvPr id="18" name="Shape 14"/>
-          <p:cNvSpPr/>
-          <p:nvPr/>
-        </p:nvSpPr>
-        <p:spPr>
-          <a:xfrm>
-            <a:off x="939798" y="4806938"/>
-            <a:ext cx="380999" cy="380999"/>
-          </a:xfrm>
-          <a:prstGeom prst="roundRect">
-            <a:avLst>
-              <a:gd name="adj" fmla="val 23333"/>
-            </a:avLst>
-          </a:prstGeom>
-          <a:solidFill>
-            <a:srgbClr val="DDEBF3"/>
-          </a:solidFill>
-          <a:ln/>
-        </p:spPr>
-      </p:sp>
-      <p:pic>
-        <p:nvPicPr>
-          <p:cNvPr id="19" name="Image 2" descr="preencoded.png">    </p:cNvPr>
-          <p:cNvPicPr>
-            <a:picLocks noChangeAspect="1"/>
-          </p:cNvPicPr>
-          <p:nvPr/>
-        </p:nvPicPr>
-        <p:blipFill>
-          <a:blip r:embed="rId3"/>
-          <a:stretch>
-            <a:fillRect/>
-          </a:stretch>
-        </p:blipFill>
-        <p:spPr>
-          <a:xfrm>
-            <a:off x="1035047" y="4902188"/>
-            <a:ext cx="190500" cy="190500"/>
-          </a:xfrm>
-          <a:prstGeom prst="rect">
-            <a:avLst/>
-          </a:prstGeom>
-        </p:spPr>
-      </p:pic>
-      <p:sp>
-        <p:nvSpPr>
-          <p:cNvPr id="20" name="Text 15"/>
-          <p:cNvSpPr txBox="1"/>
-          <p:nvPr/>
-        </p:nvSpPr>
-        <p:spPr>
-          <a:xfrm>
-            <a:off x="1549396" y="4781538"/>
-            <a:ext cx="4127490" cy="279399"/>
-          </a:xfrm>
-          <a:prstGeom prst="rect">
-            <a:avLst/>
-          </a:prstGeom>
-          <a:noFill/>
-          <a:ln/>
-        </p:spPr>
-        <p:txBody>
-          <a:bodyPr wrap="square" lIns="0" tIns="0" rIns="0" bIns="0" rtlCol="0" anchor="ctr"/>
-          <a:lstStyle/>
-          <a:p>
-            <a:pPr indent="0" marL="0">
-              <a:buNone/>
-            </a:pPr>
-            <a:r>
-              <a:rPr lang="en-US" sz="1450" b="1" dirty="0">
-                <a:solidFill>
-                  <a:srgbClr val="1C2230"/>
-                </a:solidFill>
-                <a:latin typeface="Arial" pitchFamily="34" charset="0"/>
-                <a:ea typeface="Arial" pitchFamily="34" charset="-122"/>
-                <a:cs typeface="Arial" pitchFamily="34" charset="-120"/>
-              </a:rPr>
-              <a:t>Goedkeuring belscript</a:t>
-            </a:r>
-            <a:endParaRPr lang="en-US" sz="1450" dirty="0"/>
-          </a:p>
-        </p:txBody>
-      </p:sp>
-      <p:sp>
-        <p:nvSpPr>
-          <p:cNvPr id="21" name="Text 16"/>
-          <p:cNvSpPr txBox="1"/>
-          <p:nvPr/>
-        </p:nvSpPr>
-        <p:spPr>
-          <a:xfrm>
-            <a:off x="1549396" y="5111737"/>
-            <a:ext cx="4063990" cy="698498"/>
+              <a:rPr lang="en-US" sz="1150" b="1" dirty="0">
+                <a:solidFill>
+                  <a:srgbClr val="38B6FF"/>
+                </a:solidFill>
+                <a:latin typeface="Arial" pitchFamily="34" charset="0"/>
+                <a:ea typeface="Arial" pitchFamily="34" charset="-122"/>
+                <a:cs typeface="Arial" pitchFamily="34" charset="-120"/>
+              </a:rPr>
+              <a:t>Boven target delen we mee</a:t>
+            </a:r>
+            <a:endParaRPr lang="en-US" sz="1150" dirty="0"/>
+          </a:p>
+        </p:txBody>
+      </p:sp>
+      <p:sp>
+        <p:nvSpPr>
+          <p:cNvPr id="26" name="Text 24"/>
+          <p:cNvSpPr txBox="1"/>
+          <p:nvPr/>
+        </p:nvSpPr>
+        <p:spPr>
+          <a:xfrm>
+            <a:off x="9169377" y="3924290"/>
+            <a:ext cx="2197095" cy="1079497"/>
           </a:xfrm>
           <a:prstGeom prst="rect">
             <a:avLst/>
@@ -10191,103 +11953,55 @@
           <a:p>
             <a:pPr indent="0" marL="0">
               <a:lnSpc>
-                <a:spcPct val="135000"/>
+                <a:spcPct val="130000"/>
               </a:lnSpc>
               <a:buNone/>
             </a:pPr>
             <a:r>
-              <a:rPr lang="en-US" sz="1050" dirty="0">
-                <a:solidFill>
-                  <a:srgbClr val="6F6A5C"/>
-                </a:solidFill>
-                <a:latin typeface="Arial" pitchFamily="34" charset="0"/>
-                <a:ea typeface="Arial" pitchFamily="34" charset="-122"/>
-                <a:cs typeface="Arial" pitchFamily="34" charset="-120"/>
-              </a:rPr>
-              <a:t>Wij schrijven, jullie lezen mee en keuren goed.</a:t>
-            </a:r>
-            <a:endParaRPr lang="en-US" sz="1050" dirty="0"/>
-          </a:p>
-        </p:txBody>
-      </p:sp>
-      <p:sp>
-        <p:nvSpPr>
-          <p:cNvPr id="22" name="Shape 17"/>
+              <a:rPr lang="en-US" sz="875" dirty="0">
+                <a:solidFill>
+                  <a:srgbClr val="C2C8D2"/>
+                </a:solidFill>
+                <a:latin typeface="Arial" pitchFamily="34" charset="0"/>
+                <a:ea typeface="Arial" pitchFamily="34" charset="-122"/>
+                <a:cs typeface="Arial" pitchFamily="34" charset="-120"/>
+              </a:rPr>
+              <a:t>Komen er meer afspraken uit dan afgesproken, dan spreken we daar vooraf een bonus voor af. Zo blijft doorpakken voor ons allebei interessant.</a:t>
+            </a:r>
+            <a:endParaRPr lang="en-US" sz="875" dirty="0"/>
+          </a:p>
+        </p:txBody>
+      </p:sp>
+      <p:sp>
+        <p:nvSpPr>
+          <p:cNvPr id="27" name="Shape 25"/>
           <p:cNvSpPr/>
           <p:nvPr/>
         </p:nvSpPr>
         <p:spPr>
           <a:xfrm>
-            <a:off x="6184885" y="4502139"/>
-            <a:ext cx="5397487" cy="1530346"/>
-          </a:xfrm>
-          <a:prstGeom prst="roundRect">
-            <a:avLst>
-              <a:gd name="adj" fmla="val 6639"/>
-            </a:avLst>
+            <a:off x="609598" y="5854685"/>
+            <a:ext cx="76200" cy="76200"/>
+          </a:xfrm>
+          <a:prstGeom prst="ellipse">
+            <a:avLst/>
           </a:prstGeom>
           <a:solidFill>
-            <a:srgbClr val="F8F4EB"/>
+            <a:srgbClr val="38B6FF"/>
           </a:solidFill>
           <a:ln/>
         </p:spPr>
       </p:sp>
       <p:sp>
         <p:nvSpPr>
-          <p:cNvPr id="23" name="Shape 18"/>
-          <p:cNvSpPr/>
-          <p:nvPr/>
-        </p:nvSpPr>
-        <p:spPr>
-          <a:xfrm>
-            <a:off x="6515084" y="4806938"/>
-            <a:ext cx="380999" cy="380999"/>
-          </a:xfrm>
-          <a:prstGeom prst="roundRect">
-            <a:avLst>
-              <a:gd name="adj" fmla="val 23333"/>
-            </a:avLst>
-          </a:prstGeom>
-          <a:solidFill>
-            <a:srgbClr val="DDEBF3"/>
-          </a:solidFill>
-          <a:ln/>
-        </p:spPr>
-      </p:sp>
-      <p:pic>
-        <p:nvPicPr>
-          <p:cNvPr id="24" name="Image 3" descr="preencoded.png">    </p:cNvPr>
-          <p:cNvPicPr>
-            <a:picLocks noChangeAspect="1"/>
-          </p:cNvPicPr>
-          <p:nvPr/>
-        </p:nvPicPr>
-        <p:blipFill>
-          <a:blip r:embed="rId4"/>
-          <a:stretch>
-            <a:fillRect/>
-          </a:stretch>
-        </p:blipFill>
-        <p:spPr>
-          <a:xfrm>
-            <a:off x="6610333" y="4902188"/>
-            <a:ext cx="190500" cy="190500"/>
-          </a:xfrm>
-          <a:prstGeom prst="rect">
-            <a:avLst/>
-          </a:prstGeom>
-        </p:spPr>
-      </p:pic>
-      <p:sp>
-        <p:nvSpPr>
-          <p:cNvPr id="25" name="Text 19"/>
-          <p:cNvSpPr txBox="1"/>
-          <p:nvPr/>
-        </p:nvSpPr>
-        <p:spPr>
-          <a:xfrm>
-            <a:off x="7124682" y="4781538"/>
-            <a:ext cx="4127490" cy="279399"/>
+          <p:cNvPr id="28" name="Text 26"/>
+          <p:cNvSpPr txBox="1"/>
+          <p:nvPr/>
+        </p:nvSpPr>
+        <p:spPr>
+          <a:xfrm>
+            <a:off x="800098" y="5714986"/>
+            <a:ext cx="9905975" cy="355599"/>
           </a:xfrm>
           <a:prstGeom prst="rect">
             <a:avLst/>
@@ -10303,59 +12017,17 @@
               <a:buNone/>
             </a:pPr>
             <a:r>
-              <a:rPr lang="en-US" sz="1450" b="1" dirty="0">
-                <a:solidFill>
-                  <a:srgbClr val="1C2230"/>
-                </a:solidFill>
-                <a:latin typeface="Arial" pitchFamily="34" charset="0"/>
-                <a:ea typeface="Arial" pitchFamily="34" charset="-122"/>
-                <a:cs typeface="Arial" pitchFamily="34" charset="-120"/>
-              </a:rPr>
-              <a:t>Opvolging van afspraken</a:t>
-            </a:r>
-            <a:endParaRPr lang="en-US" sz="1450" dirty="0"/>
-          </a:p>
-        </p:txBody>
-      </p:sp>
-      <p:sp>
-        <p:nvSpPr>
-          <p:cNvPr id="26" name="Text 20"/>
-          <p:cNvSpPr txBox="1"/>
-          <p:nvPr/>
-        </p:nvSpPr>
-        <p:spPr>
-          <a:xfrm>
-            <a:off x="7124682" y="5111737"/>
-            <a:ext cx="4063990" cy="698498"/>
-          </a:xfrm>
-          <a:prstGeom prst="rect">
-            <a:avLst/>
-          </a:prstGeom>
-          <a:noFill/>
-          <a:ln/>
-        </p:spPr>
-        <p:txBody>
-          <a:bodyPr wrap="square" lIns="0" tIns="0" rIns="0" bIns="0" rtlCol="0" anchor="t"/>
-          <a:lstStyle/>
-          <a:p>
-            <a:pPr indent="0" marL="0">
-              <a:lnSpc>
-                <a:spcPct val="135000"/>
-              </a:lnSpc>
-              <a:buNone/>
-            </a:pPr>
-            <a:r>
-              <a:rPr lang="en-US" sz="1050" dirty="0">
-                <a:solidFill>
-                  <a:srgbClr val="6F6A5C"/>
-                </a:solidFill>
-                <a:latin typeface="Arial" pitchFamily="34" charset="0"/>
-                <a:ea typeface="Arial" pitchFamily="34" charset="-122"/>
-                <a:cs typeface="Arial" pitchFamily="34" charset="-120"/>
-              </a:rPr>
-              <a:t>Eén vaste persoon bij Sparely die de afspraken voert en ons kort laat weten hoe ze verliepen.</a:t>
-            </a:r>
-            <a:endParaRPr lang="en-US" sz="1050" dirty="0"/>
+              <a:rPr lang="en-US" sz="1200" b="1" dirty="0">
+                <a:solidFill>
+                  <a:srgbClr val="F2EFE6"/>
+                </a:solidFill>
+                <a:latin typeface="Arial" pitchFamily="34" charset="0"/>
+                <a:ea typeface="Arial" pitchFamily="34" charset="-122"/>
+                <a:cs typeface="Arial" pitchFamily="34" charset="-120"/>
+              </a:rPr>
+              <a:t>Elke drie werkperiodes herijken we het target samen. Verandert de markt of de doelgroep, dan verandert het getal mee.</a:t>
+            </a:r>
+            <a:endParaRPr lang="en-US" sz="1200" dirty="0"/>
           </a:p>
         </p:txBody>
       </p:sp>
@@ -10516,7 +12188,7 @@
                 <a:ea typeface="Arial" pitchFamily="34" charset="-122"/>
                 <a:cs typeface="Arial" pitchFamily="34" charset="-120"/>
               </a:rPr>
-              <a:t>9 / 10</a:t>
+              <a:t>9 / 11</a:t>
             </a:r>
             <a:endParaRPr lang="en-US" sz="750" dirty="0"/>
           </a:p>
@@ -10555,7 +12227,7 @@
                 <a:ea typeface="Arial" pitchFamily="34" charset="-122"/>
                 <a:cs typeface="Arial" pitchFamily="34" charset="-120"/>
               </a:rPr>
-              <a:t>SPELREGELS</a:t>
+              <a:t>WAT WE VAN JULLIE NODIG HEBBEN</a:t>
             </a:r>
             <a:endParaRPr lang="en-US" sz="950" dirty="0"/>
           </a:p>
@@ -10597,7 +12269,7 @@
                 <a:ea typeface="Arial" pitchFamily="34" charset="-122"/>
                 <a:cs typeface="Arial" pitchFamily="34" charset="-120"/>
               </a:rPr>
-              <a:t>Transparant en zonder </a:t>
+              <a:t>Een halve dag van jullie, dan </a:t>
             </a:r>
             <a:pPr algn="l" indent="0" marL="0">
               <a:lnSpc>
@@ -10614,7 +12286,7 @@
                 <a:ea typeface="Georgia" pitchFamily="34" charset="-122"/>
                 <a:cs typeface="Georgia" pitchFamily="34" charset="-120"/>
               </a:rPr>
-              <a:t>kleine lettertjes</a:t>
+              <a:t>draaien wij</a:t>
             </a:r>
             <a:pPr algn="l" indent="0" marL="0">
               <a:lnSpc>
@@ -10645,12 +12317,34 @@
         </p:nvSpPr>
         <p:spPr>
           <a:xfrm>
-            <a:off x="609598" y="2819393"/>
-            <a:ext cx="253999" cy="253999"/>
+            <a:off x="609598" y="2793993"/>
+            <a:ext cx="5397487" cy="1530346"/>
           </a:xfrm>
           <a:prstGeom prst="roundRect">
             <a:avLst>
-              <a:gd name="adj" fmla="val 25000"/>
+              <a:gd name="adj" fmla="val 6639"/>
+            </a:avLst>
+          </a:prstGeom>
+          <a:solidFill>
+            <a:srgbClr val="F8F4EB"/>
+          </a:solidFill>
+          <a:ln/>
+        </p:spPr>
+      </p:sp>
+      <p:sp>
+        <p:nvSpPr>
+          <p:cNvPr id="8" name="Shape 6"/>
+          <p:cNvSpPr/>
+          <p:nvPr/>
+        </p:nvSpPr>
+        <p:spPr>
+          <a:xfrm>
+            <a:off x="939798" y="3098792"/>
+            <a:ext cx="380999" cy="380999"/>
+          </a:xfrm>
+          <a:prstGeom prst="roundRect">
+            <a:avLst>
+              <a:gd name="adj" fmla="val 23333"/>
             </a:avLst>
           </a:prstGeom>
           <a:solidFill>
@@ -10661,7 +12355,7 @@
       </p:sp>
       <p:pic>
         <p:nvPicPr>
-          <p:cNvPr id="8" name="Image 0" descr="preencoded.png">    </p:cNvPr>
+          <p:cNvPr id="9" name="Image 0" descr="preencoded.png">    </p:cNvPr>
           <p:cNvPicPr>
             <a:picLocks noChangeAspect="1"/>
           </p:cNvPicPr>
@@ -10675,8 +12369,8 @@
         </p:blipFill>
         <p:spPr>
           <a:xfrm>
-            <a:off x="666748" y="2876543"/>
-            <a:ext cx="139700" cy="139700"/>
+            <a:off x="1035047" y="3194042"/>
+            <a:ext cx="190500" cy="190500"/>
           </a:xfrm>
           <a:prstGeom prst="rect">
             <a:avLst/>
@@ -10685,14 +12379,14 @@
       </p:pic>
       <p:sp>
         <p:nvSpPr>
-          <p:cNvPr id="9" name="Text 6"/>
-          <p:cNvSpPr txBox="1"/>
-          <p:nvPr/>
-        </p:nvSpPr>
-        <p:spPr>
-          <a:xfrm>
-            <a:off x="1015997" y="2793993"/>
-            <a:ext cx="4825988" cy="228599"/>
+          <p:cNvPr id="10" name="Text 7"/>
+          <p:cNvSpPr txBox="1"/>
+          <p:nvPr/>
+        </p:nvSpPr>
+        <p:spPr>
+          <a:xfrm>
+            <a:off x="1549396" y="3073392"/>
+            <a:ext cx="4127490" cy="279399"/>
           </a:xfrm>
           <a:prstGeom prst="rect">
             <a:avLst/>
@@ -10708,7 +12402,7 @@
               <a:buNone/>
             </a:pPr>
             <a:r>
-              <a:rPr lang="en-US" sz="1200" b="1" dirty="0">
+              <a:rPr lang="en-US" sz="1450" b="1" dirty="0">
                 <a:solidFill>
                   <a:srgbClr val="1C2230"/>
                 </a:solidFill>
@@ -10716,22 +12410,22 @@
                 <a:ea typeface="Arial" pitchFamily="34" charset="-122"/>
                 <a:cs typeface="Arial" pitchFamily="34" charset="-120"/>
               </a:rPr>
-              <a:t>Niet-exclusief</a:t>
-            </a:r>
-            <a:endParaRPr lang="en-US" sz="1200" dirty="0"/>
-          </a:p>
-        </p:txBody>
-      </p:sp>
-      <p:sp>
-        <p:nvSpPr>
-          <p:cNvPr id="10" name="Text 7"/>
-          <p:cNvSpPr txBox="1"/>
-          <p:nvPr/>
-        </p:nvSpPr>
-        <p:spPr>
-          <a:xfrm>
-            <a:off x="1015997" y="3035292"/>
-            <a:ext cx="4825988" cy="355599"/>
+              <a:t>Kick-off sessie</a:t>
+            </a:r>
+            <a:endParaRPr lang="en-US" sz="1450" dirty="0"/>
+          </a:p>
+        </p:txBody>
+      </p:sp>
+      <p:sp>
+        <p:nvSpPr>
+          <p:cNvPr id="11" name="Text 8"/>
+          <p:cNvSpPr txBox="1"/>
+          <p:nvPr/>
+        </p:nvSpPr>
+        <p:spPr>
+          <a:xfrm>
+            <a:off x="1549396" y="3403591"/>
+            <a:ext cx="4063990" cy="698498"/>
           </a:xfrm>
           <a:prstGeom prst="rect">
             <a:avLst/>
@@ -10745,12 +12439,12 @@
           <a:p>
             <a:pPr indent="0" marL="0">
               <a:lnSpc>
-                <a:spcPct val="130000"/>
+                <a:spcPct val="135000"/>
               </a:lnSpc>
               <a:buNone/>
             </a:pPr>
             <a:r>
-              <a:rPr lang="en-US" sz="950" dirty="0">
+              <a:rPr lang="en-US" sz="1050" dirty="0">
                 <a:solidFill>
                   <a:srgbClr val="6F6A5C"/>
                 </a:solidFill>
@@ -10758,26 +12452,48 @@
                 <a:ea typeface="Arial" pitchFamily="34" charset="-122"/>
                 <a:cs typeface="Arial" pitchFamily="34" charset="-120"/>
               </a:rPr>
-              <a:t>Jullie zitten nergens aan vast en houden alle vrijheid.</a:t>
-            </a:r>
-            <a:endParaRPr lang="en-US" sz="950" dirty="0"/>
-          </a:p>
-        </p:txBody>
-      </p:sp>
-      <p:sp>
-        <p:nvSpPr>
-          <p:cNvPr id="11" name="Shape 8"/>
+              <a:t>Anderhalf tot twee uur met Bernhard en degene die de afspraken gaat voeren.</a:t>
+            </a:r>
+            <a:endParaRPr lang="en-US" sz="1050" dirty="0"/>
+          </a:p>
+        </p:txBody>
+      </p:sp>
+      <p:sp>
+        <p:nvSpPr>
+          <p:cNvPr id="12" name="Shape 9"/>
           <p:cNvSpPr/>
           <p:nvPr/>
         </p:nvSpPr>
         <p:spPr>
           <a:xfrm>
-            <a:off x="6349984" y="2819393"/>
-            <a:ext cx="253999" cy="253999"/>
+            <a:off x="6184885" y="2793993"/>
+            <a:ext cx="5397487" cy="1530346"/>
           </a:xfrm>
           <a:prstGeom prst="roundRect">
             <a:avLst>
-              <a:gd name="adj" fmla="val 25000"/>
+              <a:gd name="adj" fmla="val 6639"/>
+            </a:avLst>
+          </a:prstGeom>
+          <a:solidFill>
+            <a:srgbClr val="F8F4EB"/>
+          </a:solidFill>
+          <a:ln/>
+        </p:spPr>
+      </p:sp>
+      <p:sp>
+        <p:nvSpPr>
+          <p:cNvPr id="13" name="Shape 10"/>
+          <p:cNvSpPr/>
+          <p:nvPr/>
+        </p:nvSpPr>
+        <p:spPr>
+          <a:xfrm>
+            <a:off x="6515084" y="3098792"/>
+            <a:ext cx="380999" cy="380999"/>
+          </a:xfrm>
+          <a:prstGeom prst="roundRect">
+            <a:avLst>
+              <a:gd name="adj" fmla="val 23333"/>
             </a:avLst>
           </a:prstGeom>
           <a:solidFill>
@@ -10788,7 +12504,7 @@
       </p:sp>
       <p:pic>
         <p:nvPicPr>
-          <p:cNvPr id="12" name="Image 1" descr="preencoded.png">    </p:cNvPr>
+          <p:cNvPr id="14" name="Image 1" descr="preencoded.png">    </p:cNvPr>
           <p:cNvPicPr>
             <a:picLocks noChangeAspect="1"/>
           </p:cNvPicPr>
@@ -10802,8 +12518,8 @@
         </p:blipFill>
         <p:spPr>
           <a:xfrm>
-            <a:off x="6407134" y="2876543"/>
-            <a:ext cx="139700" cy="139700"/>
+            <a:off x="6610333" y="3194042"/>
+            <a:ext cx="190500" cy="190500"/>
           </a:xfrm>
           <a:prstGeom prst="rect">
             <a:avLst/>
@@ -10812,14 +12528,14 @@
       </p:pic>
       <p:sp>
         <p:nvSpPr>
-          <p:cNvPr id="13" name="Text 9"/>
-          <p:cNvSpPr txBox="1"/>
-          <p:nvPr/>
-        </p:nvSpPr>
-        <p:spPr>
-          <a:xfrm>
-            <a:off x="6756383" y="2793993"/>
-            <a:ext cx="4825988" cy="228599"/>
+          <p:cNvPr id="15" name="Text 11"/>
+          <p:cNvSpPr txBox="1"/>
+          <p:nvPr/>
+        </p:nvSpPr>
+        <p:spPr>
+          <a:xfrm>
+            <a:off x="7124682" y="3073392"/>
+            <a:ext cx="4127490" cy="279399"/>
           </a:xfrm>
           <a:prstGeom prst="rect">
             <a:avLst/>
@@ -10835,7 +12551,7 @@
               <a:buNone/>
             </a:pPr>
             <a:r>
-              <a:rPr lang="en-US" sz="1200" b="1" dirty="0">
+              <a:rPr lang="en-US" sz="1450" b="1" dirty="0">
                 <a:solidFill>
                   <a:srgbClr val="1C2230"/>
                 </a:solidFill>
@@ -10843,22 +12559,22 @@
                 <a:ea typeface="Arial" pitchFamily="34" charset="-122"/>
                 <a:cs typeface="Arial" pitchFamily="34" charset="-120"/>
               </a:rPr>
-              <a:t>Bestaande relaties blijven van jullie</a:t>
-            </a:r>
-            <a:endParaRPr lang="en-US" sz="1200" dirty="0"/>
-          </a:p>
-        </p:txBody>
-      </p:sp>
-      <p:sp>
-        <p:nvSpPr>
-          <p:cNvPr id="14" name="Text 10"/>
-          <p:cNvSpPr txBox="1"/>
-          <p:nvPr/>
-        </p:nvSpPr>
-        <p:spPr>
-          <a:xfrm>
-            <a:off x="6756383" y="3035292"/>
-            <a:ext cx="4825988" cy="355599"/>
+              <a:t>Uitsluitlijst</a:t>
+            </a:r>
+            <a:endParaRPr lang="en-US" sz="1450" dirty="0"/>
+          </a:p>
+        </p:txBody>
+      </p:sp>
+      <p:sp>
+        <p:nvSpPr>
+          <p:cNvPr id="16" name="Text 12"/>
+          <p:cNvSpPr txBox="1"/>
+          <p:nvPr/>
+        </p:nvSpPr>
+        <p:spPr>
+          <a:xfrm>
+            <a:off x="7124682" y="3403591"/>
+            <a:ext cx="4063990" cy="698498"/>
           </a:xfrm>
           <a:prstGeom prst="rect">
             <a:avLst/>
@@ -10872,12 +12588,12 @@
           <a:p>
             <a:pPr indent="0" marL="0">
               <a:lnSpc>
-                <a:spcPct val="130000"/>
+                <a:spcPct val="135000"/>
               </a:lnSpc>
               <a:buNone/>
             </a:pPr>
             <a:r>
-              <a:rPr lang="en-US" sz="950" dirty="0">
+              <a:rPr lang="en-US" sz="1050" dirty="0">
                 <a:solidFill>
                   <a:srgbClr val="6F6A5C"/>
                 </a:solidFill>
@@ -10885,49 +12601,48 @@
                 <a:ea typeface="Arial" pitchFamily="34" charset="-122"/>
                 <a:cs typeface="Arial" pitchFamily="34" charset="-120"/>
               </a:rPr>
-              <a:t>Uitsluitlijst vooraf, die bedrijven benaderen wij niet.</a:t>
-            </a:r>
-            <a:endParaRPr lang="en-US" sz="950" dirty="0"/>
-          </a:p>
-        </p:txBody>
-      </p:sp>
-      <p:sp>
-        <p:nvSpPr>
-          <p:cNvPr id="15" name="Shape 11"/>
+              <a:t>Bestaande klanten, lopende gesprekken en bedrijven die we niet mogen benaderen.</a:t>
+            </a:r>
+            <a:endParaRPr lang="en-US" sz="1050" dirty="0"/>
+          </a:p>
+        </p:txBody>
+      </p:sp>
+      <p:sp>
+        <p:nvSpPr>
+          <p:cNvPr id="17" name="Shape 13"/>
           <p:cNvSpPr/>
           <p:nvPr/>
         </p:nvSpPr>
         <p:spPr>
           <a:xfrm>
-            <a:off x="609598" y="3428991"/>
-            <a:ext cx="5232387" cy="0"/>
-          </a:xfrm>
-          <a:prstGeom prst="line">
-            <a:avLst/>
-          </a:prstGeom>
-          <a:noFill/>
-          <a:ln w="6350">
-            <a:solidFill>
-              <a:srgbClr val="C9C2B2"/>
-            </a:solidFill>
-            <a:prstDash val="solid"/>
-          </a:ln>
-        </p:spPr>
-      </p:sp>
-      <p:sp>
-        <p:nvSpPr>
-          <p:cNvPr id="16" name="Shape 12"/>
-          <p:cNvSpPr/>
-          <p:nvPr/>
-        </p:nvSpPr>
-        <p:spPr>
-          <a:xfrm>
-            <a:off x="609598" y="3530591"/>
-            <a:ext cx="253999" cy="253999"/>
+            <a:off x="609598" y="4502139"/>
+            <a:ext cx="5397487" cy="1530346"/>
           </a:xfrm>
           <a:prstGeom prst="roundRect">
             <a:avLst>
-              <a:gd name="adj" fmla="val 25000"/>
+              <a:gd name="adj" fmla="val 6639"/>
+            </a:avLst>
+          </a:prstGeom>
+          <a:solidFill>
+            <a:srgbClr val="F8F4EB"/>
+          </a:solidFill>
+          <a:ln/>
+        </p:spPr>
+      </p:sp>
+      <p:sp>
+        <p:nvSpPr>
+          <p:cNvPr id="18" name="Shape 14"/>
+          <p:cNvSpPr/>
+          <p:nvPr/>
+        </p:nvSpPr>
+        <p:spPr>
+          <a:xfrm>
+            <a:off x="939798" y="4806938"/>
+            <a:ext cx="380999" cy="380999"/>
+          </a:xfrm>
+          <a:prstGeom prst="roundRect">
+            <a:avLst>
+              <a:gd name="adj" fmla="val 23333"/>
             </a:avLst>
           </a:prstGeom>
           <a:solidFill>
@@ -10938,7 +12653,7 @@
       </p:sp>
       <p:pic>
         <p:nvPicPr>
-          <p:cNvPr id="17" name="Image 2" descr="preencoded.png">    </p:cNvPr>
+          <p:cNvPr id="19" name="Image 2" descr="preencoded.png">    </p:cNvPr>
           <p:cNvPicPr>
             <a:picLocks noChangeAspect="1"/>
           </p:cNvPicPr>
@@ -10952,8 +12667,8 @@
         </p:blipFill>
         <p:spPr>
           <a:xfrm>
-            <a:off x="666748" y="3587741"/>
-            <a:ext cx="139700" cy="139700"/>
+            <a:off x="1035047" y="4902188"/>
+            <a:ext cx="190500" cy="190500"/>
           </a:xfrm>
           <a:prstGeom prst="rect">
             <a:avLst/>
@@ -10962,14 +12677,14 @@
       </p:pic>
       <p:sp>
         <p:nvSpPr>
-          <p:cNvPr id="18" name="Text 13"/>
-          <p:cNvSpPr txBox="1"/>
-          <p:nvPr/>
-        </p:nvSpPr>
-        <p:spPr>
-          <a:xfrm>
-            <a:off x="1015997" y="3505191"/>
-            <a:ext cx="4825988" cy="228599"/>
+          <p:cNvPr id="20" name="Text 15"/>
+          <p:cNvSpPr txBox="1"/>
+          <p:nvPr/>
+        </p:nvSpPr>
+        <p:spPr>
+          <a:xfrm>
+            <a:off x="1549396" y="4781538"/>
+            <a:ext cx="4127490" cy="279399"/>
           </a:xfrm>
           <a:prstGeom prst="rect">
             <a:avLst/>
@@ -10985,7 +12700,7 @@
               <a:buNone/>
             </a:pPr>
             <a:r>
-              <a:rPr lang="en-US" sz="1200" b="1" dirty="0">
+              <a:rPr lang="en-US" sz="1450" b="1" dirty="0">
                 <a:solidFill>
                   <a:srgbClr val="1C2230"/>
                 </a:solidFill>
@@ -10993,22 +12708,22 @@
                 <a:ea typeface="Arial" pitchFamily="34" charset="-122"/>
                 <a:cs typeface="Arial" pitchFamily="34" charset="-120"/>
               </a:rPr>
-              <a:t>Werkperiodes van 4 weken</a:t>
-            </a:r>
-            <a:endParaRPr lang="en-US" sz="1200" dirty="0"/>
-          </a:p>
-        </p:txBody>
-      </p:sp>
-      <p:sp>
-        <p:nvSpPr>
-          <p:cNvPr id="19" name="Text 14"/>
-          <p:cNvSpPr txBox="1"/>
-          <p:nvPr/>
-        </p:nvSpPr>
-        <p:spPr>
-          <a:xfrm>
-            <a:off x="1015997" y="3746491"/>
-            <a:ext cx="4825988" cy="355599"/>
+              <a:t>Goedkeuring belscript</a:t>
+            </a:r>
+            <a:endParaRPr lang="en-US" sz="1450" dirty="0"/>
+          </a:p>
+        </p:txBody>
+      </p:sp>
+      <p:sp>
+        <p:nvSpPr>
+          <p:cNvPr id="21" name="Text 16"/>
+          <p:cNvSpPr txBox="1"/>
+          <p:nvPr/>
+        </p:nvSpPr>
+        <p:spPr>
+          <a:xfrm>
+            <a:off x="1549396" y="5111737"/>
+            <a:ext cx="4063990" cy="698498"/>
           </a:xfrm>
           <a:prstGeom prst="rect">
             <a:avLst/>
@@ -11022,12 +12737,12 @@
           <a:p>
             <a:pPr indent="0" marL="0">
               <a:lnSpc>
-                <a:spcPct val="130000"/>
+                <a:spcPct val="135000"/>
               </a:lnSpc>
               <a:buNone/>
             </a:pPr>
             <a:r>
-              <a:rPr lang="en-US" sz="950" dirty="0">
+              <a:rPr lang="en-US" sz="1050" dirty="0">
                 <a:solidFill>
                   <a:srgbClr val="6F6A5C"/>
                 </a:solidFill>
@@ -11035,49 +12750,48 @@
                 <a:ea typeface="Arial" pitchFamily="34" charset="-122"/>
                 <a:cs typeface="Arial" pitchFamily="34" charset="-120"/>
               </a:rPr>
-              <a:t>Vooraf gefactureerd, per werkperiode.</a:t>
-            </a:r>
-            <a:endParaRPr lang="en-US" sz="950" dirty="0"/>
-          </a:p>
-        </p:txBody>
-      </p:sp>
-      <p:sp>
-        <p:nvSpPr>
-          <p:cNvPr id="20" name="Shape 15"/>
+              <a:t>Wij schrijven, jullie lezen mee en keuren goed.</a:t>
+            </a:r>
+            <a:endParaRPr lang="en-US" sz="1050" dirty="0"/>
+          </a:p>
+        </p:txBody>
+      </p:sp>
+      <p:sp>
+        <p:nvSpPr>
+          <p:cNvPr id="22" name="Shape 17"/>
           <p:cNvSpPr/>
           <p:nvPr/>
         </p:nvSpPr>
         <p:spPr>
           <a:xfrm>
-            <a:off x="6349984" y="3428991"/>
-            <a:ext cx="5232387" cy="0"/>
-          </a:xfrm>
-          <a:prstGeom prst="line">
-            <a:avLst/>
-          </a:prstGeom>
-          <a:noFill/>
-          <a:ln w="6350">
-            <a:solidFill>
-              <a:srgbClr val="C9C2B2"/>
-            </a:solidFill>
-            <a:prstDash val="solid"/>
-          </a:ln>
-        </p:spPr>
-      </p:sp>
-      <p:sp>
-        <p:nvSpPr>
-          <p:cNvPr id="21" name="Shape 16"/>
-          <p:cNvSpPr/>
-          <p:nvPr/>
-        </p:nvSpPr>
-        <p:spPr>
-          <a:xfrm>
-            <a:off x="6349984" y="3530591"/>
-            <a:ext cx="253999" cy="253999"/>
+            <a:off x="6184885" y="4502139"/>
+            <a:ext cx="5397487" cy="1530346"/>
           </a:xfrm>
           <a:prstGeom prst="roundRect">
             <a:avLst>
-              <a:gd name="adj" fmla="val 25000"/>
+              <a:gd name="adj" fmla="val 6639"/>
+            </a:avLst>
+          </a:prstGeom>
+          <a:solidFill>
+            <a:srgbClr val="F8F4EB"/>
+          </a:solidFill>
+          <a:ln/>
+        </p:spPr>
+      </p:sp>
+      <p:sp>
+        <p:nvSpPr>
+          <p:cNvPr id="23" name="Shape 18"/>
+          <p:cNvSpPr/>
+          <p:nvPr/>
+        </p:nvSpPr>
+        <p:spPr>
+          <a:xfrm>
+            <a:off x="6515084" y="4806938"/>
+            <a:ext cx="380999" cy="380999"/>
+          </a:xfrm>
+          <a:prstGeom prst="roundRect">
+            <a:avLst>
+              <a:gd name="adj" fmla="val 23333"/>
             </a:avLst>
           </a:prstGeom>
           <a:solidFill>
@@ -11088,7 +12802,7 @@
       </p:sp>
       <p:pic>
         <p:nvPicPr>
-          <p:cNvPr id="22" name="Image 3" descr="preencoded.png">    </p:cNvPr>
+          <p:cNvPr id="24" name="Image 3" descr="preencoded.png">    </p:cNvPr>
           <p:cNvPicPr>
             <a:picLocks noChangeAspect="1"/>
           </p:cNvPicPr>
@@ -11102,8 +12816,8 @@
         </p:blipFill>
         <p:spPr>
           <a:xfrm>
-            <a:off x="6407134" y="3587741"/>
-            <a:ext cx="139700" cy="139700"/>
+            <a:off x="6610333" y="4902188"/>
+            <a:ext cx="190500" cy="190500"/>
           </a:xfrm>
           <a:prstGeom prst="rect">
             <a:avLst/>
@@ -11112,14 +12826,14 @@
       </p:pic>
       <p:sp>
         <p:nvSpPr>
-          <p:cNvPr id="23" name="Text 17"/>
-          <p:cNvSpPr txBox="1"/>
-          <p:nvPr/>
-        </p:nvSpPr>
-        <p:spPr>
-          <a:xfrm>
-            <a:off x="6756383" y="3505191"/>
-            <a:ext cx="4825988" cy="228599"/>
+          <p:cNvPr id="25" name="Text 19"/>
+          <p:cNvSpPr txBox="1"/>
+          <p:nvPr/>
+        </p:nvSpPr>
+        <p:spPr>
+          <a:xfrm>
+            <a:off x="7124682" y="4781538"/>
+            <a:ext cx="4127490" cy="279399"/>
           </a:xfrm>
           <a:prstGeom prst="rect">
             <a:avLst/>
@@ -11135,7 +12849,7 @@
               <a:buNone/>
             </a:pPr>
             <a:r>
-              <a:rPr lang="en-US" sz="1200" b="1" dirty="0">
+              <a:rPr lang="en-US" sz="1450" b="1" dirty="0">
                 <a:solidFill>
                   <a:srgbClr val="1C2230"/>
                 </a:solidFill>
@@ -11143,22 +12857,22 @@
                 <a:ea typeface="Arial" pitchFamily="34" charset="-122"/>
                 <a:cs typeface="Arial" pitchFamily="34" charset="-120"/>
               </a:rPr>
-              <a:t>Wekelijkse rapportage</a:t>
-            </a:r>
-            <a:endParaRPr lang="en-US" sz="1200" dirty="0"/>
-          </a:p>
-        </p:txBody>
-      </p:sp>
-      <p:sp>
-        <p:nvSpPr>
-          <p:cNvPr id="24" name="Text 18"/>
-          <p:cNvSpPr txBox="1"/>
-          <p:nvPr/>
-        </p:nvSpPr>
-        <p:spPr>
-          <a:xfrm>
-            <a:off x="6756383" y="3746491"/>
-            <a:ext cx="4825988" cy="355599"/>
+              <a:t>Opvolging van afspraken</a:t>
+            </a:r>
+            <a:endParaRPr lang="en-US" sz="1450" dirty="0"/>
+          </a:p>
+        </p:txBody>
+      </p:sp>
+      <p:sp>
+        <p:nvSpPr>
+          <p:cNvPr id="26" name="Text 20"/>
+          <p:cNvSpPr txBox="1"/>
+          <p:nvPr/>
+        </p:nvSpPr>
+        <p:spPr>
+          <a:xfrm>
+            <a:off x="7124682" y="5111737"/>
+            <a:ext cx="4063990" cy="698498"/>
           </a:xfrm>
           <a:prstGeom prst="rect">
             <a:avLst/>
@@ -11172,12 +12886,12 @@
           <a:p>
             <a:pPr indent="0" marL="0">
               <a:lnSpc>
-                <a:spcPct val="130000"/>
+                <a:spcPct val="135000"/>
               </a:lnSpc>
               <a:buNone/>
             </a:pPr>
             <a:r>
-              <a:rPr lang="en-US" sz="950" dirty="0">
+              <a:rPr lang="en-US" sz="1050" dirty="0">
                 <a:solidFill>
                   <a:srgbClr val="6F6A5C"/>
                 </a:solidFill>
@@ -11185,609 +12899,9 @@
                 <a:ea typeface="Arial" pitchFamily="34" charset="-122"/>
                 <a:cs typeface="Arial" pitchFamily="34" charset="-120"/>
               </a:rPr>
-              <a:t>Elke week zicht op wat er gebeurd is en wat het opleverde.</a:t>
-            </a:r>
-            <a:endParaRPr lang="en-US" sz="950" dirty="0"/>
-          </a:p>
-        </p:txBody>
-      </p:sp>
-      <p:sp>
-        <p:nvSpPr>
-          <p:cNvPr id="25" name="Shape 19"/>
-          <p:cNvSpPr/>
-          <p:nvPr/>
-        </p:nvSpPr>
-        <p:spPr>
-          <a:xfrm>
-            <a:off x="609598" y="4140190"/>
-            <a:ext cx="5232387" cy="0"/>
-          </a:xfrm>
-          <a:prstGeom prst="line">
-            <a:avLst/>
-          </a:prstGeom>
-          <a:noFill/>
-          <a:ln w="6350">
-            <a:solidFill>
-              <a:srgbClr val="C9C2B2"/>
-            </a:solidFill>
-            <a:prstDash val="solid"/>
-          </a:ln>
-        </p:spPr>
-      </p:sp>
-      <p:sp>
-        <p:nvSpPr>
-          <p:cNvPr id="26" name="Shape 20"/>
-          <p:cNvSpPr/>
-          <p:nvPr/>
-        </p:nvSpPr>
-        <p:spPr>
-          <a:xfrm>
-            <a:off x="609598" y="4241789"/>
-            <a:ext cx="253999" cy="253999"/>
-          </a:xfrm>
-          <a:prstGeom prst="roundRect">
-            <a:avLst>
-              <a:gd name="adj" fmla="val 25000"/>
-            </a:avLst>
-          </a:prstGeom>
-          <a:solidFill>
-            <a:srgbClr val="DDEBF3"/>
-          </a:solidFill>
-          <a:ln/>
-        </p:spPr>
-      </p:sp>
-      <p:pic>
-        <p:nvPicPr>
-          <p:cNvPr id="27" name="Image 4" descr="preencoded.png">    </p:cNvPr>
-          <p:cNvPicPr>
-            <a:picLocks noChangeAspect="1"/>
-          </p:cNvPicPr>
-          <p:nvPr/>
-        </p:nvPicPr>
-        <p:blipFill>
-          <a:blip r:embed="rId5"/>
-          <a:stretch>
-            <a:fillRect/>
-          </a:stretch>
-        </p:blipFill>
-        <p:spPr>
-          <a:xfrm>
-            <a:off x="666748" y="4298939"/>
-            <a:ext cx="139700" cy="139700"/>
-          </a:xfrm>
-          <a:prstGeom prst="rect">
-            <a:avLst/>
-          </a:prstGeom>
-        </p:spPr>
-      </p:pic>
-      <p:sp>
-        <p:nvSpPr>
-          <p:cNvPr id="28" name="Text 21"/>
-          <p:cNvSpPr txBox="1"/>
-          <p:nvPr/>
-        </p:nvSpPr>
-        <p:spPr>
-          <a:xfrm>
-            <a:off x="1015997" y="4216389"/>
-            <a:ext cx="4825988" cy="228599"/>
-          </a:xfrm>
-          <a:prstGeom prst="rect">
-            <a:avLst/>
-          </a:prstGeom>
-          <a:noFill/>
-          <a:ln/>
-        </p:spPr>
-        <p:txBody>
-          <a:bodyPr wrap="square" lIns="0" tIns="0" rIns="0" bIns="0" rtlCol="0" anchor="ctr"/>
-          <a:lstStyle/>
-          <a:p>
-            <a:pPr indent="0" marL="0">
-              <a:buNone/>
-            </a:pPr>
-            <a:r>
-              <a:rPr lang="en-US" sz="1200" b="1" dirty="0">
-                <a:solidFill>
-                  <a:srgbClr val="1C2230"/>
-                </a:solidFill>
-                <a:latin typeface="Arial" pitchFamily="34" charset="0"/>
-                <a:ea typeface="Arial" pitchFamily="34" charset="-122"/>
-                <a:cs typeface="Arial" pitchFamily="34" charset="-120"/>
-              </a:rPr>
-              <a:t>Jullie naam, onze uitvoering</a:t>
-            </a:r>
-            <a:endParaRPr lang="en-US" sz="1200" dirty="0"/>
-          </a:p>
-        </p:txBody>
-      </p:sp>
-      <p:sp>
-        <p:nvSpPr>
-          <p:cNvPr id="29" name="Text 22"/>
-          <p:cNvSpPr txBox="1"/>
-          <p:nvPr/>
-        </p:nvSpPr>
-        <p:spPr>
-          <a:xfrm>
-            <a:off x="1015997" y="4457689"/>
-            <a:ext cx="4825988" cy="355599"/>
-          </a:xfrm>
-          <a:prstGeom prst="rect">
-            <a:avLst/>
-          </a:prstGeom>
-          <a:noFill/>
-          <a:ln/>
-        </p:spPr>
-        <p:txBody>
-          <a:bodyPr wrap="square" lIns="0" tIns="0" rIns="0" bIns="0" rtlCol="0" anchor="t"/>
-          <a:lstStyle/>
-          <a:p>
-            <a:pPr indent="0" marL="0">
-              <a:lnSpc>
-                <a:spcPct val="130000"/>
-              </a:lnSpc>
-              <a:buNone/>
-            </a:pPr>
-            <a:r>
-              <a:rPr lang="en-US" sz="950" dirty="0">
-                <a:solidFill>
-                  <a:srgbClr val="6F6A5C"/>
-                </a:solidFill>
-                <a:latin typeface="Arial" pitchFamily="34" charset="0"/>
-                <a:ea typeface="Arial" pitchFamily="34" charset="-122"/>
-                <a:cs typeface="Arial" pitchFamily="34" charset="-120"/>
-              </a:rPr>
-              <a:t>Regionaal nummer en jullie stijl, wij voeren uit.</a:t>
-            </a:r>
-            <a:endParaRPr lang="en-US" sz="950" dirty="0"/>
-          </a:p>
-        </p:txBody>
-      </p:sp>
-      <p:sp>
-        <p:nvSpPr>
-          <p:cNvPr id="30" name="Shape 23"/>
-          <p:cNvSpPr/>
-          <p:nvPr/>
-        </p:nvSpPr>
-        <p:spPr>
-          <a:xfrm>
-            <a:off x="6349984" y="4140190"/>
-            <a:ext cx="5232387" cy="0"/>
-          </a:xfrm>
-          <a:prstGeom prst="line">
-            <a:avLst/>
-          </a:prstGeom>
-          <a:noFill/>
-          <a:ln w="6350">
-            <a:solidFill>
-              <a:srgbClr val="C9C2B2"/>
-            </a:solidFill>
-            <a:prstDash val="solid"/>
-          </a:ln>
-        </p:spPr>
-      </p:sp>
-      <p:sp>
-        <p:nvSpPr>
-          <p:cNvPr id="31" name="Shape 24"/>
-          <p:cNvSpPr/>
-          <p:nvPr/>
-        </p:nvSpPr>
-        <p:spPr>
-          <a:xfrm>
-            <a:off x="6349984" y="4241789"/>
-            <a:ext cx="253999" cy="253999"/>
-          </a:xfrm>
-          <a:prstGeom prst="roundRect">
-            <a:avLst>
-              <a:gd name="adj" fmla="val 25000"/>
-            </a:avLst>
-          </a:prstGeom>
-          <a:solidFill>
-            <a:srgbClr val="DDEBF3"/>
-          </a:solidFill>
-          <a:ln/>
-        </p:spPr>
-      </p:sp>
-      <p:pic>
-        <p:nvPicPr>
-          <p:cNvPr id="32" name="Image 5" descr="preencoded.png">    </p:cNvPr>
-          <p:cNvPicPr>
-            <a:picLocks noChangeAspect="1"/>
-          </p:cNvPicPr>
-          <p:nvPr/>
-        </p:nvPicPr>
-        <p:blipFill>
-          <a:blip r:embed="rId6"/>
-          <a:stretch>
-            <a:fillRect/>
-          </a:stretch>
-        </p:blipFill>
-        <p:spPr>
-          <a:xfrm>
-            <a:off x="6407134" y="4298939"/>
-            <a:ext cx="139700" cy="139700"/>
-          </a:xfrm>
-          <a:prstGeom prst="rect">
-            <a:avLst/>
-          </a:prstGeom>
-        </p:spPr>
-      </p:pic>
-      <p:sp>
-        <p:nvSpPr>
-          <p:cNvPr id="33" name="Text 25"/>
-          <p:cNvSpPr txBox="1"/>
-          <p:nvPr/>
-        </p:nvSpPr>
-        <p:spPr>
-          <a:xfrm>
-            <a:off x="6756383" y="4216389"/>
-            <a:ext cx="4825988" cy="228599"/>
-          </a:xfrm>
-          <a:prstGeom prst="rect">
-            <a:avLst/>
-          </a:prstGeom>
-          <a:noFill/>
-          <a:ln/>
-        </p:spPr>
-        <p:txBody>
-          <a:bodyPr wrap="square" lIns="0" tIns="0" rIns="0" bIns="0" rtlCol="0" anchor="ctr"/>
-          <a:lstStyle/>
-          <a:p>
-            <a:pPr indent="0" marL="0">
-              <a:buNone/>
-            </a:pPr>
-            <a:r>
-              <a:rPr lang="en-US" sz="1200" b="1" dirty="0">
-                <a:solidFill>
-                  <a:srgbClr val="1C2230"/>
-                </a:solidFill>
-                <a:latin typeface="Arial" pitchFamily="34" charset="0"/>
-                <a:ea typeface="Arial" pitchFamily="34" charset="-122"/>
-                <a:cs typeface="Arial" pitchFamily="34" charset="-120"/>
-              </a:rPr>
-              <a:t>Gegevens veilig</a:t>
-            </a:r>
-            <a:endParaRPr lang="en-US" sz="1200" dirty="0"/>
-          </a:p>
-        </p:txBody>
-      </p:sp>
-      <p:sp>
-        <p:nvSpPr>
-          <p:cNvPr id="34" name="Text 26"/>
-          <p:cNvSpPr txBox="1"/>
-          <p:nvPr/>
-        </p:nvSpPr>
-        <p:spPr>
-          <a:xfrm>
-            <a:off x="6756383" y="4457689"/>
-            <a:ext cx="4825988" cy="355599"/>
-          </a:xfrm>
-          <a:prstGeom prst="rect">
-            <a:avLst/>
-          </a:prstGeom>
-          <a:noFill/>
-          <a:ln/>
-        </p:spPr>
-        <p:txBody>
-          <a:bodyPr wrap="square" lIns="0" tIns="0" rIns="0" bIns="0" rtlCol="0" anchor="t"/>
-          <a:lstStyle/>
-          <a:p>
-            <a:pPr indent="0" marL="0">
-              <a:lnSpc>
-                <a:spcPct val="130000"/>
-              </a:lnSpc>
-              <a:buNone/>
-            </a:pPr>
-            <a:r>
-              <a:rPr lang="en-US" sz="950" dirty="0">
-                <a:solidFill>
-                  <a:srgbClr val="6F6A5C"/>
-                </a:solidFill>
-                <a:latin typeface="Arial" pitchFamily="34" charset="0"/>
-                <a:ea typeface="Arial" pitchFamily="34" charset="-122"/>
-                <a:cs typeface="Arial" pitchFamily="34" charset="-120"/>
-              </a:rPr>
-              <a:t>Vastgelegd in een verwerkersovereenkomst.</a:t>
-            </a:r>
-            <a:endParaRPr lang="en-US" sz="950" dirty="0"/>
-          </a:p>
-        </p:txBody>
-      </p:sp>
-      <p:sp>
-        <p:nvSpPr>
-          <p:cNvPr id="35" name="Shape 27"/>
-          <p:cNvSpPr/>
-          <p:nvPr/>
-        </p:nvSpPr>
-        <p:spPr>
-          <a:xfrm>
-            <a:off x="609598" y="4851388"/>
-            <a:ext cx="5232387" cy="0"/>
-          </a:xfrm>
-          <a:prstGeom prst="line">
-            <a:avLst/>
-          </a:prstGeom>
-          <a:noFill/>
-          <a:ln w="6350">
-            <a:solidFill>
-              <a:srgbClr val="C9C2B2"/>
-            </a:solidFill>
-            <a:prstDash val="solid"/>
-          </a:ln>
-        </p:spPr>
-      </p:sp>
-      <p:sp>
-        <p:nvSpPr>
-          <p:cNvPr id="36" name="Shape 28"/>
-          <p:cNvSpPr/>
-          <p:nvPr/>
-        </p:nvSpPr>
-        <p:spPr>
-          <a:xfrm>
-            <a:off x="609598" y="4952988"/>
-            <a:ext cx="253999" cy="253999"/>
-          </a:xfrm>
-          <a:prstGeom prst="roundRect">
-            <a:avLst>
-              <a:gd name="adj" fmla="val 25000"/>
-            </a:avLst>
-          </a:prstGeom>
-          <a:solidFill>
-            <a:srgbClr val="DDEBF3"/>
-          </a:solidFill>
-          <a:ln/>
-        </p:spPr>
-      </p:sp>
-      <p:pic>
-        <p:nvPicPr>
-          <p:cNvPr id="37" name="Image 6" descr="preencoded.png">    </p:cNvPr>
-          <p:cNvPicPr>
-            <a:picLocks noChangeAspect="1"/>
-          </p:cNvPicPr>
-          <p:nvPr/>
-        </p:nvPicPr>
-        <p:blipFill>
-          <a:blip r:embed="rId7"/>
-          <a:stretch>
-            <a:fillRect/>
-          </a:stretch>
-        </p:blipFill>
-        <p:spPr>
-          <a:xfrm>
-            <a:off x="666748" y="5010137"/>
-            <a:ext cx="139700" cy="139700"/>
-          </a:xfrm>
-          <a:prstGeom prst="rect">
-            <a:avLst/>
-          </a:prstGeom>
-        </p:spPr>
-      </p:pic>
-      <p:sp>
-        <p:nvSpPr>
-          <p:cNvPr id="38" name="Text 29"/>
-          <p:cNvSpPr txBox="1"/>
-          <p:nvPr/>
-        </p:nvSpPr>
-        <p:spPr>
-          <a:xfrm>
-            <a:off x="1015997" y="4927588"/>
-            <a:ext cx="4825988" cy="228599"/>
-          </a:xfrm>
-          <a:prstGeom prst="rect">
-            <a:avLst/>
-          </a:prstGeom>
-          <a:noFill/>
-          <a:ln/>
-        </p:spPr>
-        <p:txBody>
-          <a:bodyPr wrap="square" lIns="0" tIns="0" rIns="0" bIns="0" rtlCol="0" anchor="ctr"/>
-          <a:lstStyle/>
-          <a:p>
-            <a:pPr indent="0" marL="0">
-              <a:buNone/>
-            </a:pPr>
-            <a:r>
-              <a:rPr lang="en-US" sz="1200" b="1" dirty="0">
-                <a:solidFill>
-                  <a:srgbClr val="1C2230"/>
-                </a:solidFill>
-                <a:latin typeface="Arial" pitchFamily="34" charset="0"/>
-                <a:ea typeface="Arial" pitchFamily="34" charset="-122"/>
-                <a:cs typeface="Arial" pitchFamily="34" charset="-120"/>
-              </a:rPr>
-              <a:t>Evaluatie om de week</a:t>
-            </a:r>
-            <a:endParaRPr lang="en-US" sz="1200" dirty="0"/>
-          </a:p>
-        </p:txBody>
-      </p:sp>
-      <p:sp>
-        <p:nvSpPr>
-          <p:cNvPr id="39" name="Text 30"/>
-          <p:cNvSpPr txBox="1"/>
-          <p:nvPr/>
-        </p:nvSpPr>
-        <p:spPr>
-          <a:xfrm>
-            <a:off x="1015997" y="5168887"/>
-            <a:ext cx="4825988" cy="355599"/>
-          </a:xfrm>
-          <a:prstGeom prst="rect">
-            <a:avLst/>
-          </a:prstGeom>
-          <a:noFill/>
-          <a:ln/>
-        </p:spPr>
-        <p:txBody>
-          <a:bodyPr wrap="square" lIns="0" tIns="0" rIns="0" bIns="0" rtlCol="0" anchor="t"/>
-          <a:lstStyle/>
-          <a:p>
-            <a:pPr indent="0" marL="0">
-              <a:lnSpc>
-                <a:spcPct val="130000"/>
-              </a:lnSpc>
-              <a:buNone/>
-            </a:pPr>
-            <a:r>
-              <a:rPr lang="en-US" sz="950" dirty="0">
-                <a:solidFill>
-                  <a:srgbClr val="6F6A5C"/>
-                </a:solidFill>
-                <a:latin typeface="Arial" pitchFamily="34" charset="0"/>
-                <a:ea typeface="Arial" pitchFamily="34" charset="-122"/>
-                <a:cs typeface="Arial" pitchFamily="34" charset="-120"/>
-              </a:rPr>
-              <a:t>Bij twijfel om tafel en bijsturen.</a:t>
-            </a:r>
-            <a:endParaRPr lang="en-US" sz="950" dirty="0"/>
-          </a:p>
-        </p:txBody>
-      </p:sp>
-      <p:sp>
-        <p:nvSpPr>
-          <p:cNvPr id="40" name="Shape 31"/>
-          <p:cNvSpPr/>
-          <p:nvPr/>
-        </p:nvSpPr>
-        <p:spPr>
-          <a:xfrm>
-            <a:off x="6349984" y="4851388"/>
-            <a:ext cx="5232387" cy="0"/>
-          </a:xfrm>
-          <a:prstGeom prst="line">
-            <a:avLst/>
-          </a:prstGeom>
-          <a:noFill/>
-          <a:ln w="6350">
-            <a:solidFill>
-              <a:srgbClr val="C9C2B2"/>
-            </a:solidFill>
-            <a:prstDash val="solid"/>
-          </a:ln>
-        </p:spPr>
-      </p:sp>
-      <p:sp>
-        <p:nvSpPr>
-          <p:cNvPr id="41" name="Shape 32"/>
-          <p:cNvSpPr/>
-          <p:nvPr/>
-        </p:nvSpPr>
-        <p:spPr>
-          <a:xfrm>
-            <a:off x="6349984" y="4952988"/>
-            <a:ext cx="253999" cy="253999"/>
-          </a:xfrm>
-          <a:prstGeom prst="roundRect">
-            <a:avLst>
-              <a:gd name="adj" fmla="val 25000"/>
-            </a:avLst>
-          </a:prstGeom>
-          <a:solidFill>
-            <a:srgbClr val="DDEBF3"/>
-          </a:solidFill>
-          <a:ln/>
-        </p:spPr>
-      </p:sp>
-      <p:pic>
-        <p:nvPicPr>
-          <p:cNvPr id="42" name="Image 7" descr="preencoded.png">    </p:cNvPr>
-          <p:cNvPicPr>
-            <a:picLocks noChangeAspect="1"/>
-          </p:cNvPicPr>
-          <p:nvPr/>
-        </p:nvPicPr>
-        <p:blipFill>
-          <a:blip r:embed="rId8"/>
-          <a:stretch>
-            <a:fillRect/>
-          </a:stretch>
-        </p:blipFill>
-        <p:spPr>
-          <a:xfrm>
-            <a:off x="6407134" y="5010137"/>
-            <a:ext cx="139700" cy="139700"/>
-          </a:xfrm>
-          <a:prstGeom prst="rect">
-            <a:avLst/>
-          </a:prstGeom>
-        </p:spPr>
-      </p:pic>
-      <p:sp>
-        <p:nvSpPr>
-          <p:cNvPr id="43" name="Text 33"/>
-          <p:cNvSpPr txBox="1"/>
-          <p:nvPr/>
-        </p:nvSpPr>
-        <p:spPr>
-          <a:xfrm>
-            <a:off x="6756383" y="4927588"/>
-            <a:ext cx="4825988" cy="228599"/>
-          </a:xfrm>
-          <a:prstGeom prst="rect">
-            <a:avLst/>
-          </a:prstGeom>
-          <a:noFill/>
-          <a:ln/>
-        </p:spPr>
-        <p:txBody>
-          <a:bodyPr wrap="square" lIns="0" tIns="0" rIns="0" bIns="0" rtlCol="0" anchor="ctr"/>
-          <a:lstStyle/>
-          <a:p>
-            <a:pPr indent="0" marL="0">
-              <a:buNone/>
-            </a:pPr>
-            <a:r>
-              <a:rPr lang="en-US" sz="1200" b="1" dirty="0">
-                <a:solidFill>
-                  <a:srgbClr val="1C2230"/>
-                </a:solidFill>
-                <a:latin typeface="Arial" pitchFamily="34" charset="0"/>
-                <a:ea typeface="Arial" pitchFamily="34" charset="-122"/>
-                <a:cs typeface="Arial" pitchFamily="34" charset="-120"/>
-              </a:rPr>
-              <a:t>Alles op papier</a:t>
-            </a:r>
-            <a:endParaRPr lang="en-US" sz="1200" dirty="0"/>
-          </a:p>
-        </p:txBody>
-      </p:sp>
-      <p:sp>
-        <p:nvSpPr>
-          <p:cNvPr id="44" name="Text 34"/>
-          <p:cNvSpPr txBox="1"/>
-          <p:nvPr/>
-        </p:nvSpPr>
-        <p:spPr>
-          <a:xfrm>
-            <a:off x="6756383" y="5168887"/>
-            <a:ext cx="4825988" cy="355599"/>
-          </a:xfrm>
-          <a:prstGeom prst="rect">
-            <a:avLst/>
-          </a:prstGeom>
-          <a:noFill/>
-          <a:ln/>
-        </p:spPr>
-        <p:txBody>
-          <a:bodyPr wrap="square" lIns="0" tIns="0" rIns="0" bIns="0" rtlCol="0" anchor="t"/>
-          <a:lstStyle/>
-          <a:p>
-            <a:pPr indent="0" marL="0">
-              <a:lnSpc>
-                <a:spcPct val="130000"/>
-              </a:lnSpc>
-              <a:buNone/>
-            </a:pPr>
-            <a:r>
-              <a:rPr lang="en-US" sz="950" dirty="0">
-                <a:solidFill>
-                  <a:srgbClr val="6F6A5C"/>
-                </a:solidFill>
-                <a:latin typeface="Arial" pitchFamily="34" charset="0"/>
-                <a:ea typeface="Arial" pitchFamily="34" charset="-122"/>
-                <a:cs typeface="Arial" pitchFamily="34" charset="-120"/>
-              </a:rPr>
-              <a:t>Vastgelegd in een korte samenwerkingsovereenkomst.</a:t>
-            </a:r>
-            <a:endParaRPr lang="en-US" sz="950" dirty="0"/>
+              <a:t>Eén vaste persoon bij Sparely die de afspraken voert en ons kort laat weten hoe ze verliepen.</a:t>
+            </a:r>
+            <a:endParaRPr lang="en-US" sz="1050" dirty="0"/>
           </a:p>
         </p:txBody>
       </p:sp>

</xml_diff>

<commit_message>
Vervang bonus per afspraak door succesfee bij gerealiseerde omzet
De vervolgslide legt nu uit dat de pilot meet hoeveel tijd er in
een afspraak zit en wat een afspraak daarmee kost. Extra afspraken
leveren geen extra vergoeding op, wel een vooraf afgesproken
succesfee zodra een afspraak een opdracht wordt.

Co-Authored-By: Claude Opus 5 <noreply@anthropic.com>
Claude-Session: https://claude.ai/code/session_0141FN3f3hHkYQHTyvTJJGrw
</commit_message>
<xml_diff>
--- a/output/LINK. kennismaking Sparely.pptx
+++ b/output/LINK. kennismaking Sparely.pptx
@@ -11408,7 +11408,7 @@
                 <a:ea typeface="Arial" pitchFamily="34" charset="-122"/>
                 <a:cs typeface="Arial" pitchFamily="34" charset="-120"/>
               </a:rPr>
-              <a:t>Vaste bezetting</a:t>
+              <a:t>Wat een afspraak kost</a:t>
             </a:r>
             <a:endParaRPr lang="en-US" sz="1150" dirty="0"/>
           </a:p>
@@ -11450,7 +11450,7 @@
                 <a:ea typeface="Arial" pitchFamily="34" charset="-122"/>
                 <a:cs typeface="Arial" pitchFamily="34" charset="-120"/>
               </a:rPr>
-              <a:t>Jullie kiezen hoeveel dagdelen per week we voor jullie bellen. Hoe meer bezetting, hoe scherper het tarief, want dan draait een vaste beller vol op jullie verhaal.</a:t>
+              <a:t>Uit de pilot blijkt hoeveel tijd er in één gekwalificeerde afspraak zit. Daarmee weten we hoeveel afspraken per dagdeel realistisch zijn en wat een afspraak dus kost.</a:t>
             </a:r>
             <a:endParaRPr lang="en-US" sz="875" dirty="0"/>
           </a:p>
@@ -11580,7 +11580,7 @@
                 <a:ea typeface="Arial" pitchFamily="34" charset="-122"/>
                 <a:cs typeface="Arial" pitchFamily="34" charset="-120"/>
               </a:rPr>
-              <a:t>Vast target</a:t>
+              <a:t>Vaste bezetting, vast aantal</a:t>
             </a:r>
             <a:endParaRPr lang="en-US" sz="1150" dirty="0"/>
           </a:p>
@@ -11622,7 +11622,7 @@
                 <a:ea typeface="Arial" pitchFamily="34" charset="-122"/>
                 <a:cs typeface="Arial" pitchFamily="34" charset="-120"/>
               </a:rPr>
-              <a:t>Aan die bezetting hangt een vast aantal gekwalificeerde afspraken per werkperiode. Dat getal komt uit jullie eigen pilot, niet uit een aanname.</a:t>
+              <a:t>Jullie kiezen hoeveel dagdelen per week we bellen. Met de ratio uit de pilot ligt daarmee ook vast hoeveel afspraken er per werkperiode staan.</a:t>
             </a:r>
             <a:endParaRPr lang="en-US" sz="875" dirty="0"/>
           </a:p>
@@ -11924,7 +11924,7 @@
                 <a:ea typeface="Arial" pitchFamily="34" charset="-122"/>
                 <a:cs typeface="Arial" pitchFamily="34" charset="-120"/>
               </a:rPr>
-              <a:t>Boven target delen we mee</a:t>
+              <a:t>Succesfee bij omzet</a:t>
             </a:r>
             <a:endParaRPr lang="en-US" sz="1150" dirty="0"/>
           </a:p>
@@ -11966,7 +11966,7 @@
                 <a:ea typeface="Arial" pitchFamily="34" charset="-122"/>
                 <a:cs typeface="Arial" pitchFamily="34" charset="-120"/>
               </a:rPr>
-              <a:t>Komen er meer afspraken uit dan afgesproken, dan spreken we daar vooraf een bonus voor af. Zo blijft doorpakken voor ons allebei interessant.</a:t>
+              <a:t>Wordt een afspraak een opdracht, dan spreken we daar vooraf een succesfee over af. Wij verdienen pas extra als het jullie ook echt omzet oplevert.</a:t>
             </a:r>
             <a:endParaRPr lang="en-US" sz="875" dirty="0"/>
           </a:p>

</xml_diff>

<commit_message>
Vervolgslide: gereserveerde tijd, boven target zonder extra factuur
Wij trekken de tijd uit voor het afgesproken aantal afspraken.
Zijn we eerder klaar, dan bellen we de tijd vol en komen de extra
afspraken de klant toe zonder extra factuur. Onder target staat
niet meer als aparte bouwsteen maar als uitzondering in de
afsluitregel, met compensatie in de volgende werkperiode.

Co-Authored-By: Claude Opus 5 <noreply@anthropic.com>
Claude-Session: https://claude.ai/code/session_0141FN3f3hHkYQHTyvTJJGrw
</commit_message>
<xml_diff>
--- a/output/LINK. kennismaking Sparely.pptx
+++ b/output/LINK. kennismaking Sparely.pptx
@@ -11622,7 +11622,7 @@
                 <a:ea typeface="Arial" pitchFamily="34" charset="-122"/>
                 <a:cs typeface="Arial" pitchFamily="34" charset="-120"/>
               </a:rPr>
-              <a:t>Jullie kiezen hoeveel dagdelen per week we bellen. Met de ratio uit de pilot ligt daarmee ook vast hoeveel afspraken er per werkperiode staan.</a:t>
+              <a:t>Jullie kiezen hoeveel dagdelen per week we bellen. Daar hangt een vast aantal afspraken aan en wij trekken de tijd uit die daarvoor nodig is.</a:t>
             </a:r>
             <a:endParaRPr lang="en-US" sz="875" dirty="0"/>
           </a:p>
@@ -11752,7 +11752,7 @@
                 <a:ea typeface="Arial" pitchFamily="34" charset="-122"/>
                 <a:cs typeface="Arial" pitchFamily="34" charset="-120"/>
               </a:rPr>
-              <a:t>Onder target bellen we door</a:t>
+              <a:t>Boven target is voor jullie</a:t>
             </a:r>
             <a:endParaRPr lang="en-US" sz="1150" dirty="0"/>
           </a:p>
@@ -11794,7 +11794,7 @@
                 <a:ea typeface="Arial" pitchFamily="34" charset="-122"/>
                 <a:cs typeface="Arial" pitchFamily="34" charset="-120"/>
               </a:rPr>
-              <a:t>Staat het aantal aan het eind van de werkperiode niet, dan bellen we door zonder extra kosten tot het er wel staat.</a:t>
+              <a:t>Zijn we eerder klaar dan gepland, dan bellen we de tijd gewoon vol. Wat er dan nog bij komt is voor jullie, zonder extra factuur.</a:t>
             </a:r>
             <a:endParaRPr lang="en-US" sz="875" dirty="0"/>
           </a:p>
@@ -12025,7 +12025,7 @@
                 <a:ea typeface="Arial" pitchFamily="34" charset="-122"/>
                 <a:cs typeface="Arial" pitchFamily="34" charset="-120"/>
               </a:rPr>
-              <a:t>Elke drie werkperiodes herijken we het target samen. Verandert de markt of de doelgroep, dan verandert het getal mee.</a:t>
+              <a:t>Het target komt uit jullie eigen cijfers, dus dat halen we. Zo niet, dan halen we het de volgende werkperiode in.</a:t>
             </a:r>
             <a:endParaRPr lang="en-US" sz="1200" dirty="0"/>
           </a:p>

</xml_diff>

<commit_message>
Nieuwe kop op de vervolgslide en koppen die netjes uitbalanceren
De kop leest nu 'Je koopt geen uren. Je investeert in afspraken
in de agenda.' Omdat die over twee regels loopt balanceren de
sectiekoppen voortaan uit, zodat er geen los woord op de tweede
regel achterblijft.

Co-Authored-By: Claude Opus 5 <noreply@anthropic.com>
Claude-Session: https://claude.ai/code/session_0141FN3f3hHkYQHTyvTJJGrw
</commit_message>
<xml_diff>
--- a/output/LINK. kennismaking Sparely.pptx
+++ b/output/LINK. kennismaking Sparely.pptx
@@ -8910,7 +8910,7 @@
                 <a:ea typeface="Arial" pitchFamily="34" charset="-122"/>
                 <a:cs typeface="Arial" pitchFamily="34" charset="-120"/>
               </a:rPr>
-              <a:t>Jullie kopen geen uren, maar </a:t>
+              <a:t>Je koopt geen uren. Je </a:t>
             </a:r>
             <a:pPr algn="l" indent="0" marL="0">
               <a:lnSpc>
@@ -8927,7 +8927,7 @@
                 <a:ea typeface="Georgia" pitchFamily="34" charset="-122"/>
                 <a:cs typeface="Georgia" pitchFamily="34" charset="-120"/>
               </a:rPr>
-              <a:t>afspraken</a:t>
+              <a:t>investeert</a:t>
             </a:r>
             <a:pPr algn="l" indent="0" marL="0">
               <a:lnSpc>
@@ -8944,7 +8944,7 @@
                 <a:ea typeface="Arial" pitchFamily="34" charset="-122"/>
                 <a:cs typeface="Arial" pitchFamily="34" charset="-120"/>
               </a:rPr>
-              <a:t>.</a:t>
+              <a:t> in afspraken in de agenda.</a:t>
             </a:r>
             <a:endParaRPr lang="en-US" sz="3200" dirty="0"/>
           </a:p>

</xml_diff>